<commit_message>
Adding feat/ipo_strategy_service working version of stockAnalysis web scraper and normalizer and initial IPOEvent table
</commit_message>
<xml_diff>
--- a/00_system_architecture/quant_management_platform_architecture.pptx
+++ b/00_system_architecture/quant_management_platform_architecture.pptx
@@ -4,6 +4,9 @@
   <p:sldMasterIdLst>
     <p:sldMasterId id="2147483648" r:id="rId1"/>
   </p:sldMasterIdLst>
+  <p:notesMasterIdLst>
+    <p:notesMasterId r:id="rId12"/>
+  </p:notesMasterIdLst>
   <p:sldIdLst>
     <p:sldId id="256" r:id="rId2"/>
     <p:sldId id="265" r:id="rId3"/>
@@ -113,7 +116,445 @@
       </a:defRPr>
     </a:lvl9pPr>
   </p:defaultTextStyle>
+  <p:extLst>
+    <p:ext uri="{EFAFB233-063F-42B5-8137-9DF3F51BA10A}">
+      <p15:sldGuideLst xmlns:p15="http://schemas.microsoft.com/office/powerpoint/2012/main"/>
+    </p:ext>
+  </p:extLst>
 </p:presentation>
+</file>
+
+<file path=ppt/notesMasters/notesMaster1.xml><?xml version="1.0" encoding="utf-8"?>
+<p:notesMaster xmlns:a="http://schemas.openxmlformats.org/drawingml/2006/main" xmlns:r="http://schemas.openxmlformats.org/officeDocument/2006/relationships" xmlns:p="http://schemas.openxmlformats.org/presentationml/2006/main">
+  <p:cSld>
+    <p:bg>
+      <p:bgRef idx="1001">
+        <a:schemeClr val="bg1"/>
+      </p:bgRef>
+    </p:bg>
+    <p:spTree>
+      <p:nvGrpSpPr>
+        <p:cNvPr id="1" name=""/>
+        <p:cNvGrpSpPr/>
+        <p:nvPr/>
+      </p:nvGrpSpPr>
+      <p:grpSpPr>
+        <a:xfrm>
+          <a:off x="0" y="0"/>
+          <a:ext cx="0" cy="0"/>
+          <a:chOff x="0" y="0"/>
+          <a:chExt cx="0" cy="0"/>
+        </a:xfrm>
+      </p:grpSpPr>
+      <p:sp>
+        <p:nvSpPr>
+          <p:cNvPr id="2" name="Header Placeholder 1"/>
+          <p:cNvSpPr>
+            <a:spLocks noGrp="1"/>
+          </p:cNvSpPr>
+          <p:nvPr>
+            <p:ph type="hdr" sz="quarter"/>
+          </p:nvPr>
+        </p:nvSpPr>
+        <p:spPr>
+          <a:xfrm>
+            <a:off x="0" y="0"/>
+            <a:ext cx="2971800" cy="458788"/>
+          </a:xfrm>
+          <a:prstGeom prst="rect">
+            <a:avLst/>
+          </a:prstGeom>
+        </p:spPr>
+        <p:txBody>
+          <a:bodyPr vert="horz" lIns="91440" tIns="45720" rIns="91440" bIns="45720" rtlCol="0"/>
+          <a:lstStyle>
+            <a:lvl1pPr algn="l">
+              <a:defRPr sz="1200"/>
+            </a:lvl1pPr>
+          </a:lstStyle>
+          <a:p>
+            <a:endParaRPr lang="en-US"/>
+          </a:p>
+        </p:txBody>
+      </p:sp>
+      <p:sp>
+        <p:nvSpPr>
+          <p:cNvPr id="3" name="Date Placeholder 2"/>
+          <p:cNvSpPr>
+            <a:spLocks noGrp="1"/>
+          </p:cNvSpPr>
+          <p:nvPr>
+            <p:ph type="dt" idx="1"/>
+          </p:nvPr>
+        </p:nvSpPr>
+        <p:spPr>
+          <a:xfrm>
+            <a:off x="3884613" y="0"/>
+            <a:ext cx="2971800" cy="458788"/>
+          </a:xfrm>
+          <a:prstGeom prst="rect">
+            <a:avLst/>
+          </a:prstGeom>
+        </p:spPr>
+        <p:txBody>
+          <a:bodyPr vert="horz" lIns="91440" tIns="45720" rIns="91440" bIns="45720" rtlCol="0"/>
+          <a:lstStyle>
+            <a:lvl1pPr algn="r">
+              <a:defRPr sz="1200"/>
+            </a:lvl1pPr>
+          </a:lstStyle>
+          <a:p>
+            <a:fld id="{70866825-8C01-4766-8F79-C41ECFD9525D}" type="datetimeFigureOut">
+              <a:rPr lang="en-US" smtClean="0"/>
+              <a:t>12/30/2025</a:t>
+            </a:fld>
+            <a:endParaRPr lang="en-US"/>
+          </a:p>
+        </p:txBody>
+      </p:sp>
+      <p:sp>
+        <p:nvSpPr>
+          <p:cNvPr id="4" name="Slide Image Placeholder 3"/>
+          <p:cNvSpPr>
+            <a:spLocks noGrp="1" noRot="1" noChangeAspect="1"/>
+          </p:cNvSpPr>
+          <p:nvPr>
+            <p:ph type="sldImg" idx="2"/>
+          </p:nvPr>
+        </p:nvSpPr>
+        <p:spPr>
+          <a:xfrm>
+            <a:off x="685800" y="1143000"/>
+            <a:ext cx="5486400" cy="3086100"/>
+          </a:xfrm>
+          <a:prstGeom prst="rect">
+            <a:avLst/>
+          </a:prstGeom>
+          <a:noFill/>
+          <a:ln w="12700">
+            <a:solidFill>
+              <a:prstClr val="black"/>
+            </a:solidFill>
+          </a:ln>
+        </p:spPr>
+        <p:txBody>
+          <a:bodyPr vert="horz" lIns="91440" tIns="45720" rIns="91440" bIns="45720" rtlCol="0" anchor="ctr"/>
+          <a:lstStyle/>
+          <a:p>
+            <a:endParaRPr lang="en-US"/>
+          </a:p>
+        </p:txBody>
+      </p:sp>
+      <p:sp>
+        <p:nvSpPr>
+          <p:cNvPr id="5" name="Notes Placeholder 4"/>
+          <p:cNvSpPr>
+            <a:spLocks noGrp="1"/>
+          </p:cNvSpPr>
+          <p:nvPr>
+            <p:ph type="body" sz="quarter" idx="3"/>
+          </p:nvPr>
+        </p:nvSpPr>
+        <p:spPr>
+          <a:xfrm>
+            <a:off x="685800" y="4400550"/>
+            <a:ext cx="5486400" cy="3600450"/>
+          </a:xfrm>
+          <a:prstGeom prst="rect">
+            <a:avLst/>
+          </a:prstGeom>
+        </p:spPr>
+        <p:txBody>
+          <a:bodyPr vert="horz" lIns="91440" tIns="45720" rIns="91440" bIns="45720" rtlCol="0"/>
+          <a:lstStyle/>
+          <a:p>
+            <a:pPr lvl="0"/>
+            <a:r>
+              <a:rPr lang="en-US"/>
+              <a:t>Click to edit Master text styles</a:t>
+            </a:r>
+          </a:p>
+          <a:p>
+            <a:pPr lvl="1"/>
+            <a:r>
+              <a:rPr lang="en-US"/>
+              <a:t>Second level</a:t>
+            </a:r>
+          </a:p>
+          <a:p>
+            <a:pPr lvl="2"/>
+            <a:r>
+              <a:rPr lang="en-US"/>
+              <a:t>Third level</a:t>
+            </a:r>
+          </a:p>
+          <a:p>
+            <a:pPr lvl="3"/>
+            <a:r>
+              <a:rPr lang="en-US"/>
+              <a:t>Fourth level</a:t>
+            </a:r>
+          </a:p>
+          <a:p>
+            <a:pPr lvl="4"/>
+            <a:r>
+              <a:rPr lang="en-US"/>
+              <a:t>Fifth level</a:t>
+            </a:r>
+          </a:p>
+        </p:txBody>
+      </p:sp>
+      <p:sp>
+        <p:nvSpPr>
+          <p:cNvPr id="6" name="Footer Placeholder 5"/>
+          <p:cNvSpPr>
+            <a:spLocks noGrp="1"/>
+          </p:cNvSpPr>
+          <p:nvPr>
+            <p:ph type="ftr" sz="quarter" idx="4"/>
+          </p:nvPr>
+        </p:nvSpPr>
+        <p:spPr>
+          <a:xfrm>
+            <a:off x="0" y="8685213"/>
+            <a:ext cx="2971800" cy="458787"/>
+          </a:xfrm>
+          <a:prstGeom prst="rect">
+            <a:avLst/>
+          </a:prstGeom>
+        </p:spPr>
+        <p:txBody>
+          <a:bodyPr vert="horz" lIns="91440" tIns="45720" rIns="91440" bIns="45720" rtlCol="0" anchor="b"/>
+          <a:lstStyle>
+            <a:lvl1pPr algn="l">
+              <a:defRPr sz="1200"/>
+            </a:lvl1pPr>
+          </a:lstStyle>
+          <a:p>
+            <a:endParaRPr lang="en-US"/>
+          </a:p>
+        </p:txBody>
+      </p:sp>
+      <p:sp>
+        <p:nvSpPr>
+          <p:cNvPr id="7" name="Slide Number Placeholder 6"/>
+          <p:cNvSpPr>
+            <a:spLocks noGrp="1"/>
+          </p:cNvSpPr>
+          <p:nvPr>
+            <p:ph type="sldNum" sz="quarter" idx="5"/>
+          </p:nvPr>
+        </p:nvSpPr>
+        <p:spPr>
+          <a:xfrm>
+            <a:off x="3884613" y="8685213"/>
+            <a:ext cx="2971800" cy="458787"/>
+          </a:xfrm>
+          <a:prstGeom prst="rect">
+            <a:avLst/>
+          </a:prstGeom>
+        </p:spPr>
+        <p:txBody>
+          <a:bodyPr vert="horz" lIns="91440" tIns="45720" rIns="91440" bIns="45720" rtlCol="0" anchor="b"/>
+          <a:lstStyle>
+            <a:lvl1pPr algn="r">
+              <a:defRPr sz="1200"/>
+            </a:lvl1pPr>
+          </a:lstStyle>
+          <a:p>
+            <a:fld id="{1A238C5B-EE31-4EFC-BE39-0EEC656BD8F3}" type="slidenum">
+              <a:rPr lang="en-US" smtClean="0"/>
+              <a:t>‹#›</a:t>
+            </a:fld>
+            <a:endParaRPr lang="en-US"/>
+          </a:p>
+        </p:txBody>
+      </p:sp>
+    </p:spTree>
+    <p:extLst>
+      <p:ext uri="{BB962C8B-B14F-4D97-AF65-F5344CB8AC3E}">
+        <p14:creationId xmlns:p14="http://schemas.microsoft.com/office/powerpoint/2010/main" val="3960272104"/>
+      </p:ext>
+    </p:extLst>
+  </p:cSld>
+  <p:clrMap bg1="lt1" tx1="dk1" bg2="lt2" tx2="dk2" accent1="accent1" accent2="accent2" accent3="accent3" accent4="accent4" accent5="accent5" accent6="accent6" hlink="hlink" folHlink="folHlink"/>
+  <p:notesStyle>
+    <a:lvl1pPr marL="0" algn="l" defTabSz="914400" rtl="0" eaLnBrk="1" latinLnBrk="0" hangingPunct="1">
+      <a:defRPr sz="1200" kern="1200">
+        <a:solidFill>
+          <a:schemeClr val="tx1"/>
+        </a:solidFill>
+        <a:latin typeface="+mn-lt"/>
+        <a:ea typeface="+mn-ea"/>
+        <a:cs typeface="+mn-cs"/>
+      </a:defRPr>
+    </a:lvl1pPr>
+    <a:lvl2pPr marL="457200" algn="l" defTabSz="914400" rtl="0" eaLnBrk="1" latinLnBrk="0" hangingPunct="1">
+      <a:defRPr sz="1200" kern="1200">
+        <a:solidFill>
+          <a:schemeClr val="tx1"/>
+        </a:solidFill>
+        <a:latin typeface="+mn-lt"/>
+        <a:ea typeface="+mn-ea"/>
+        <a:cs typeface="+mn-cs"/>
+      </a:defRPr>
+    </a:lvl2pPr>
+    <a:lvl3pPr marL="914400" algn="l" defTabSz="914400" rtl="0" eaLnBrk="1" latinLnBrk="0" hangingPunct="1">
+      <a:defRPr sz="1200" kern="1200">
+        <a:solidFill>
+          <a:schemeClr val="tx1"/>
+        </a:solidFill>
+        <a:latin typeface="+mn-lt"/>
+        <a:ea typeface="+mn-ea"/>
+        <a:cs typeface="+mn-cs"/>
+      </a:defRPr>
+    </a:lvl3pPr>
+    <a:lvl4pPr marL="1371600" algn="l" defTabSz="914400" rtl="0" eaLnBrk="1" latinLnBrk="0" hangingPunct="1">
+      <a:defRPr sz="1200" kern="1200">
+        <a:solidFill>
+          <a:schemeClr val="tx1"/>
+        </a:solidFill>
+        <a:latin typeface="+mn-lt"/>
+        <a:ea typeface="+mn-ea"/>
+        <a:cs typeface="+mn-cs"/>
+      </a:defRPr>
+    </a:lvl4pPr>
+    <a:lvl5pPr marL="1828800" algn="l" defTabSz="914400" rtl="0" eaLnBrk="1" latinLnBrk="0" hangingPunct="1">
+      <a:defRPr sz="1200" kern="1200">
+        <a:solidFill>
+          <a:schemeClr val="tx1"/>
+        </a:solidFill>
+        <a:latin typeface="+mn-lt"/>
+        <a:ea typeface="+mn-ea"/>
+        <a:cs typeface="+mn-cs"/>
+      </a:defRPr>
+    </a:lvl5pPr>
+    <a:lvl6pPr marL="2286000" algn="l" defTabSz="914400" rtl="0" eaLnBrk="1" latinLnBrk="0" hangingPunct="1">
+      <a:defRPr sz="1200" kern="1200">
+        <a:solidFill>
+          <a:schemeClr val="tx1"/>
+        </a:solidFill>
+        <a:latin typeface="+mn-lt"/>
+        <a:ea typeface="+mn-ea"/>
+        <a:cs typeface="+mn-cs"/>
+      </a:defRPr>
+    </a:lvl6pPr>
+    <a:lvl7pPr marL="2743200" algn="l" defTabSz="914400" rtl="0" eaLnBrk="1" latinLnBrk="0" hangingPunct="1">
+      <a:defRPr sz="1200" kern="1200">
+        <a:solidFill>
+          <a:schemeClr val="tx1"/>
+        </a:solidFill>
+        <a:latin typeface="+mn-lt"/>
+        <a:ea typeface="+mn-ea"/>
+        <a:cs typeface="+mn-cs"/>
+      </a:defRPr>
+    </a:lvl7pPr>
+    <a:lvl8pPr marL="3200400" algn="l" defTabSz="914400" rtl="0" eaLnBrk="1" latinLnBrk="0" hangingPunct="1">
+      <a:defRPr sz="1200" kern="1200">
+        <a:solidFill>
+          <a:schemeClr val="tx1"/>
+        </a:solidFill>
+        <a:latin typeface="+mn-lt"/>
+        <a:ea typeface="+mn-ea"/>
+        <a:cs typeface="+mn-cs"/>
+      </a:defRPr>
+    </a:lvl8pPr>
+    <a:lvl9pPr marL="3657600" algn="l" defTabSz="914400" rtl="0" eaLnBrk="1" latinLnBrk="0" hangingPunct="1">
+      <a:defRPr sz="1200" kern="1200">
+        <a:solidFill>
+          <a:schemeClr val="tx1"/>
+        </a:solidFill>
+        <a:latin typeface="+mn-lt"/>
+        <a:ea typeface="+mn-ea"/>
+        <a:cs typeface="+mn-cs"/>
+      </a:defRPr>
+    </a:lvl9pPr>
+  </p:notesStyle>
+</p:notesMaster>
+</file>
+
+<file path=ppt/notesSlides/notesSlide1.xml><?xml version="1.0" encoding="utf-8"?>
+<p:notes xmlns:a="http://schemas.openxmlformats.org/drawingml/2006/main" xmlns:r="http://schemas.openxmlformats.org/officeDocument/2006/relationships" xmlns:p="http://schemas.openxmlformats.org/presentationml/2006/main">
+  <p:cSld>
+    <p:spTree>
+      <p:nvGrpSpPr>
+        <p:cNvPr id="1" name=""/>
+        <p:cNvGrpSpPr/>
+        <p:nvPr/>
+      </p:nvGrpSpPr>
+      <p:grpSpPr>
+        <a:xfrm>
+          <a:off x="0" y="0"/>
+          <a:ext cx="0" cy="0"/>
+          <a:chOff x="0" y="0"/>
+          <a:chExt cx="0" cy="0"/>
+        </a:xfrm>
+      </p:grpSpPr>
+      <p:sp>
+        <p:nvSpPr>
+          <p:cNvPr id="2" name="Slide Image Placeholder 1"/>
+          <p:cNvSpPr>
+            <a:spLocks noGrp="1" noRot="1" noChangeAspect="1"/>
+          </p:cNvSpPr>
+          <p:nvPr>
+            <p:ph type="sldImg"/>
+          </p:nvPr>
+        </p:nvSpPr>
+        <p:spPr/>
+      </p:sp>
+      <p:sp>
+        <p:nvSpPr>
+          <p:cNvPr id="3" name="Notes Placeholder 2"/>
+          <p:cNvSpPr>
+            <a:spLocks noGrp="1"/>
+          </p:cNvSpPr>
+          <p:nvPr>
+            <p:ph type="body" idx="1"/>
+          </p:nvPr>
+        </p:nvSpPr>
+        <p:spPr/>
+        <p:txBody>
+          <a:bodyPr/>
+          <a:lstStyle/>
+          <a:p>
+            <a:endParaRPr lang="en-US" dirty="0"/>
+          </a:p>
+        </p:txBody>
+      </p:sp>
+      <p:sp>
+        <p:nvSpPr>
+          <p:cNvPr id="4" name="Slide Number Placeholder 3"/>
+          <p:cNvSpPr>
+            <a:spLocks noGrp="1"/>
+          </p:cNvSpPr>
+          <p:nvPr>
+            <p:ph type="sldNum" sz="quarter" idx="5"/>
+          </p:nvPr>
+        </p:nvSpPr>
+        <p:spPr/>
+        <p:txBody>
+          <a:bodyPr/>
+          <a:lstStyle/>
+          <a:p>
+            <a:fld id="{1A238C5B-EE31-4EFC-BE39-0EEC656BD8F3}" type="slidenum">
+              <a:rPr lang="en-US" smtClean="0"/>
+              <a:t>4</a:t>
+            </a:fld>
+            <a:endParaRPr lang="en-US"/>
+          </a:p>
+        </p:txBody>
+      </p:sp>
+    </p:spTree>
+    <p:extLst>
+      <p:ext uri="{BB962C8B-B14F-4D97-AF65-F5344CB8AC3E}">
+        <p14:creationId xmlns:p14="http://schemas.microsoft.com/office/powerpoint/2010/main" val="411527830"/>
+      </p:ext>
+    </p:extLst>
+  </p:cSld>
+  <p:clrMapOvr>
+    <a:masterClrMapping/>
+  </p:clrMapOvr>
+</p:notes>
 </file>
 
 <file path=ppt/slideLayouts/slideLayout1.xml><?xml version="1.0" encoding="utf-8"?>
@@ -263,7 +704,7 @@
           <a:p>
             <a:fld id="{7CD6D201-3712-4708-B8BD-34638CB62F40}" type="datetimeFigureOut">
               <a:rPr lang="en-US" smtClean="0"/>
-              <a:t>12/21/2025</a:t>
+              <a:t>12/30/2025</a:t>
             </a:fld>
             <a:endParaRPr lang="en-US"/>
           </a:p>
@@ -461,7 +902,7 @@
           <a:p>
             <a:fld id="{7CD6D201-3712-4708-B8BD-34638CB62F40}" type="datetimeFigureOut">
               <a:rPr lang="en-US" smtClean="0"/>
-              <a:t>12/21/2025</a:t>
+              <a:t>12/30/2025</a:t>
             </a:fld>
             <a:endParaRPr lang="en-US"/>
           </a:p>
@@ -669,7 +1110,7 @@
           <a:p>
             <a:fld id="{7CD6D201-3712-4708-B8BD-34638CB62F40}" type="datetimeFigureOut">
               <a:rPr lang="en-US" smtClean="0"/>
-              <a:t>12/21/2025</a:t>
+              <a:t>12/30/2025</a:t>
             </a:fld>
             <a:endParaRPr lang="en-US"/>
           </a:p>
@@ -867,7 +1308,7 @@
           <a:p>
             <a:fld id="{7CD6D201-3712-4708-B8BD-34638CB62F40}" type="datetimeFigureOut">
               <a:rPr lang="en-US" smtClean="0"/>
-              <a:t>12/21/2025</a:t>
+              <a:t>12/30/2025</a:t>
             </a:fld>
             <a:endParaRPr lang="en-US"/>
           </a:p>
@@ -1142,7 +1583,7 @@
           <a:p>
             <a:fld id="{7CD6D201-3712-4708-B8BD-34638CB62F40}" type="datetimeFigureOut">
               <a:rPr lang="en-US" smtClean="0"/>
-              <a:t>12/21/2025</a:t>
+              <a:t>12/30/2025</a:t>
             </a:fld>
             <a:endParaRPr lang="en-US"/>
           </a:p>
@@ -1407,7 +1848,7 @@
           <a:p>
             <a:fld id="{7CD6D201-3712-4708-B8BD-34638CB62F40}" type="datetimeFigureOut">
               <a:rPr lang="en-US" smtClean="0"/>
-              <a:t>12/21/2025</a:t>
+              <a:t>12/30/2025</a:t>
             </a:fld>
             <a:endParaRPr lang="en-US"/>
           </a:p>
@@ -1819,7 +2260,7 @@
           <a:p>
             <a:fld id="{7CD6D201-3712-4708-B8BD-34638CB62F40}" type="datetimeFigureOut">
               <a:rPr lang="en-US" smtClean="0"/>
-              <a:t>12/21/2025</a:t>
+              <a:t>12/30/2025</a:t>
             </a:fld>
             <a:endParaRPr lang="en-US"/>
           </a:p>
@@ -1960,7 +2401,7 @@
           <a:p>
             <a:fld id="{7CD6D201-3712-4708-B8BD-34638CB62F40}" type="datetimeFigureOut">
               <a:rPr lang="en-US" smtClean="0"/>
-              <a:t>12/21/2025</a:t>
+              <a:t>12/30/2025</a:t>
             </a:fld>
             <a:endParaRPr lang="en-US"/>
           </a:p>
@@ -2073,7 +2514,7 @@
           <a:p>
             <a:fld id="{7CD6D201-3712-4708-B8BD-34638CB62F40}" type="datetimeFigureOut">
               <a:rPr lang="en-US" smtClean="0"/>
-              <a:t>12/21/2025</a:t>
+              <a:t>12/30/2025</a:t>
             </a:fld>
             <a:endParaRPr lang="en-US"/>
           </a:p>
@@ -2384,7 +2825,7 @@
           <a:p>
             <a:fld id="{7CD6D201-3712-4708-B8BD-34638CB62F40}" type="datetimeFigureOut">
               <a:rPr lang="en-US" smtClean="0"/>
-              <a:t>12/21/2025</a:t>
+              <a:t>12/30/2025</a:t>
             </a:fld>
             <a:endParaRPr lang="en-US"/>
           </a:p>
@@ -2672,7 +3113,7 @@
           <a:p>
             <a:fld id="{7CD6D201-3712-4708-B8BD-34638CB62F40}" type="datetimeFigureOut">
               <a:rPr lang="en-US" smtClean="0"/>
-              <a:t>12/21/2025</a:t>
+              <a:t>12/30/2025</a:t>
             </a:fld>
             <a:endParaRPr lang="en-US"/>
           </a:p>
@@ -2913,7 +3354,7 @@
           <a:p>
             <a:fld id="{7CD6D201-3712-4708-B8BD-34638CB62F40}" type="datetimeFigureOut">
               <a:rPr lang="en-US" smtClean="0"/>
-              <a:t>12/21/2025</a:t>
+              <a:t>12/30/2025</a:t>
             </a:fld>
             <a:endParaRPr lang="en-US"/>
           </a:p>
@@ -4203,7 +4644,7 @@
         </p:nvSpPr>
         <p:spPr>
           <a:xfrm>
-            <a:off x="5578913" y="5295447"/>
+            <a:off x="1599528" y="5295447"/>
             <a:ext cx="881743" cy="1197428"/>
           </a:xfrm>
           <a:prstGeom prst="flowChartMagneticDisk">
@@ -4232,8 +4673,8 @@
           <a:p>
             <a:pPr algn="ctr"/>
             <a:r>
-              <a:rPr lang="en-US" dirty="0"/>
-              <a:t>SQLite DB</a:t>
+              <a:rPr lang="en-US" sz="1200" dirty="0"/>
+              <a:t>Market Data</a:t>
             </a:r>
           </a:p>
         </p:txBody>
@@ -4252,8 +4693,8 @@
         </p:nvSpPr>
         <p:spPr>
           <a:xfrm>
-            <a:off x="141515" y="2874282"/>
-            <a:ext cx="1600200" cy="1520598"/>
+            <a:off x="141515" y="2968266"/>
+            <a:ext cx="1600200" cy="1325563"/>
           </a:xfrm>
           <a:prstGeom prst="flowChartProcess">
             <a:avLst/>
@@ -4380,7 +4821,7 @@
             <a:pPr algn="ctr"/>
             <a:r>
               <a:rPr lang="en-US" dirty="0"/>
-              <a:t>Strategy Service</a:t>
+              <a:t>Strategy Service(s)</a:t>
             </a:r>
           </a:p>
         </p:txBody>
@@ -4722,6 +5163,7 @@
             </a:extLst>
           </p:cNvPr>
           <p:cNvCxnSpPr>
+            <a:cxnSpLocks/>
             <a:stCxn id="5" idx="3"/>
             <a:endCxn id="6" idx="1"/>
           </p:cNvCxnSpPr>
@@ -4729,8 +5171,8 @@
         </p:nvCxnSpPr>
         <p:spPr>
           <a:xfrm>
-            <a:off x="1741715" y="3634581"/>
-            <a:ext cx="468084" cy="681"/>
+            <a:off x="1741715" y="3631048"/>
+            <a:ext cx="468084" cy="4214"/>
           </a:xfrm>
           <a:prstGeom prst="straightConnector1">
             <a:avLst/>
@@ -4967,6 +5409,1025 @@
           </a:fontRef>
         </p:style>
       </p:cxnSp>
+      <p:sp>
+        <p:nvSpPr>
+          <p:cNvPr id="3" name="Flowchart: Magnetic Disk 2">
+            <a:extLst>
+              <a:ext uri="{FF2B5EF4-FFF2-40B4-BE49-F238E27FC236}">
+                <a16:creationId xmlns:a16="http://schemas.microsoft.com/office/drawing/2014/main" id="{FB9F28AB-D25B-1F70-CBE3-CDE2DF0A2F94}"/>
+              </a:ext>
+            </a:extLst>
+          </p:cNvPr>
+          <p:cNvSpPr/>
+          <p:nvPr/>
+        </p:nvSpPr>
+        <p:spPr>
+          <a:xfrm>
+            <a:off x="2563584" y="5295447"/>
+            <a:ext cx="881743" cy="1197428"/>
+          </a:xfrm>
+          <a:prstGeom prst="flowChartMagneticDisk">
+            <a:avLst/>
+          </a:prstGeom>
+        </p:spPr>
+        <p:style>
+          <a:lnRef idx="2">
+            <a:schemeClr val="accent1">
+              <a:shade val="15000"/>
+            </a:schemeClr>
+          </a:lnRef>
+          <a:fillRef idx="1">
+            <a:schemeClr val="accent1"/>
+          </a:fillRef>
+          <a:effectRef idx="0">
+            <a:schemeClr val="accent1"/>
+          </a:effectRef>
+          <a:fontRef idx="minor">
+            <a:schemeClr val="lt1"/>
+          </a:fontRef>
+        </p:style>
+        <p:txBody>
+          <a:bodyPr rtlCol="0" anchor="ctr"/>
+          <a:lstStyle/>
+          <a:p>
+            <a:pPr algn="ctr"/>
+            <a:r>
+              <a:rPr lang="en-US" sz="1200" dirty="0"/>
+              <a:t>Asset Universe</a:t>
+            </a:r>
+          </a:p>
+        </p:txBody>
+      </p:sp>
+      <p:sp>
+        <p:nvSpPr>
+          <p:cNvPr id="8" name="Flowchart: Magnetic Disk 7">
+            <a:extLst>
+              <a:ext uri="{FF2B5EF4-FFF2-40B4-BE49-F238E27FC236}">
+                <a16:creationId xmlns:a16="http://schemas.microsoft.com/office/drawing/2014/main" id="{AA02077F-8522-E2FF-FEB0-CA8EED30A369}"/>
+              </a:ext>
+            </a:extLst>
+          </p:cNvPr>
+          <p:cNvSpPr/>
+          <p:nvPr/>
+        </p:nvSpPr>
+        <p:spPr>
+          <a:xfrm>
+            <a:off x="4465886" y="5295447"/>
+            <a:ext cx="881743" cy="1197428"/>
+          </a:xfrm>
+          <a:prstGeom prst="flowChartMagneticDisk">
+            <a:avLst/>
+          </a:prstGeom>
+        </p:spPr>
+        <p:style>
+          <a:lnRef idx="2">
+            <a:schemeClr val="accent1">
+              <a:shade val="15000"/>
+            </a:schemeClr>
+          </a:lnRef>
+          <a:fillRef idx="1">
+            <a:schemeClr val="accent1"/>
+          </a:fillRef>
+          <a:effectRef idx="0">
+            <a:schemeClr val="accent1"/>
+          </a:effectRef>
+          <a:fontRef idx="minor">
+            <a:schemeClr val="lt1"/>
+          </a:fontRef>
+        </p:style>
+        <p:txBody>
+          <a:bodyPr rtlCol="0" anchor="ctr"/>
+          <a:lstStyle/>
+          <a:p>
+            <a:pPr algn="ctr"/>
+            <a:r>
+              <a:rPr lang="en-US" sz="1200" dirty="0"/>
+              <a:t>Strategy Specific Data</a:t>
+            </a:r>
+          </a:p>
+        </p:txBody>
+      </p:sp>
+      <p:sp>
+        <p:nvSpPr>
+          <p:cNvPr id="9" name="Flowchart: Magnetic Disk 8">
+            <a:extLst>
+              <a:ext uri="{FF2B5EF4-FFF2-40B4-BE49-F238E27FC236}">
+                <a16:creationId xmlns:a16="http://schemas.microsoft.com/office/drawing/2014/main" id="{A5268C0A-5895-6186-E026-2A6438180ED5}"/>
+              </a:ext>
+            </a:extLst>
+          </p:cNvPr>
+          <p:cNvSpPr/>
+          <p:nvPr/>
+        </p:nvSpPr>
+        <p:spPr>
+          <a:xfrm>
+            <a:off x="6340946" y="5295447"/>
+            <a:ext cx="881743" cy="1197428"/>
+          </a:xfrm>
+          <a:prstGeom prst="flowChartMagneticDisk">
+            <a:avLst/>
+          </a:prstGeom>
+        </p:spPr>
+        <p:style>
+          <a:lnRef idx="2">
+            <a:schemeClr val="accent1">
+              <a:shade val="15000"/>
+            </a:schemeClr>
+          </a:lnRef>
+          <a:fillRef idx="1">
+            <a:schemeClr val="accent1"/>
+          </a:fillRef>
+          <a:effectRef idx="0">
+            <a:schemeClr val="accent1"/>
+          </a:effectRef>
+          <a:fontRef idx="minor">
+            <a:schemeClr val="lt1"/>
+          </a:fontRef>
+        </p:style>
+        <p:txBody>
+          <a:bodyPr rtlCol="0" anchor="ctr"/>
+          <a:lstStyle/>
+          <a:p>
+            <a:pPr algn="ctr"/>
+            <a:r>
+              <a:rPr lang="en-US" sz="1200" dirty="0"/>
+              <a:t>Portfolio DB</a:t>
+            </a:r>
+          </a:p>
+        </p:txBody>
+      </p:sp>
+      <p:sp>
+        <p:nvSpPr>
+          <p:cNvPr id="10" name="Flowchart: Magnetic Disk 9">
+            <a:extLst>
+              <a:ext uri="{FF2B5EF4-FFF2-40B4-BE49-F238E27FC236}">
+                <a16:creationId xmlns:a16="http://schemas.microsoft.com/office/drawing/2014/main" id="{75557E9A-A2E1-3FD9-5A35-BC5960E18D9B}"/>
+              </a:ext>
+            </a:extLst>
+          </p:cNvPr>
+          <p:cNvSpPr/>
+          <p:nvPr/>
+        </p:nvSpPr>
+        <p:spPr>
+          <a:xfrm>
+            <a:off x="8284005" y="5295447"/>
+            <a:ext cx="881743" cy="1197428"/>
+          </a:xfrm>
+          <a:prstGeom prst="flowChartMagneticDisk">
+            <a:avLst/>
+          </a:prstGeom>
+        </p:spPr>
+        <p:style>
+          <a:lnRef idx="2">
+            <a:schemeClr val="accent1">
+              <a:shade val="15000"/>
+            </a:schemeClr>
+          </a:lnRef>
+          <a:fillRef idx="1">
+            <a:schemeClr val="accent1"/>
+          </a:fillRef>
+          <a:effectRef idx="0">
+            <a:schemeClr val="accent1"/>
+          </a:effectRef>
+          <a:fontRef idx="minor">
+            <a:schemeClr val="lt1"/>
+          </a:fontRef>
+        </p:style>
+        <p:txBody>
+          <a:bodyPr rtlCol="0" anchor="ctr"/>
+          <a:lstStyle/>
+          <a:p>
+            <a:pPr algn="ctr"/>
+            <a:r>
+              <a:rPr lang="en-US" sz="1200" dirty="0"/>
+              <a:t>Risk Specific Data</a:t>
+            </a:r>
+          </a:p>
+        </p:txBody>
+      </p:sp>
+      <p:sp>
+        <p:nvSpPr>
+          <p:cNvPr id="11" name="Flowchart: Magnetic Disk 10">
+            <a:extLst>
+              <a:ext uri="{FF2B5EF4-FFF2-40B4-BE49-F238E27FC236}">
+                <a16:creationId xmlns:a16="http://schemas.microsoft.com/office/drawing/2014/main" id="{9A3F3E1C-FFEA-7F41-6F31-B52AB35A4259}"/>
+              </a:ext>
+            </a:extLst>
+          </p:cNvPr>
+          <p:cNvSpPr/>
+          <p:nvPr/>
+        </p:nvSpPr>
+        <p:spPr>
+          <a:xfrm>
+            <a:off x="9965842" y="5295447"/>
+            <a:ext cx="881743" cy="1197428"/>
+          </a:xfrm>
+          <a:prstGeom prst="flowChartMagneticDisk">
+            <a:avLst/>
+          </a:prstGeom>
+        </p:spPr>
+        <p:style>
+          <a:lnRef idx="2">
+            <a:schemeClr val="accent1">
+              <a:shade val="15000"/>
+            </a:schemeClr>
+          </a:lnRef>
+          <a:fillRef idx="1">
+            <a:schemeClr val="accent1"/>
+          </a:fillRef>
+          <a:effectRef idx="0">
+            <a:schemeClr val="accent1"/>
+          </a:effectRef>
+          <a:fontRef idx="minor">
+            <a:schemeClr val="lt1"/>
+          </a:fontRef>
+        </p:style>
+        <p:txBody>
+          <a:bodyPr rtlCol="0" anchor="ctr"/>
+          <a:lstStyle/>
+          <a:p>
+            <a:pPr algn="ctr"/>
+            <a:r>
+              <a:rPr lang="en-US" sz="1200" dirty="0"/>
+              <a:t>Trade History</a:t>
+            </a:r>
+          </a:p>
+        </p:txBody>
+      </p:sp>
+      <p:sp>
+        <p:nvSpPr>
+          <p:cNvPr id="12" name="Flowchart: Magnetic Disk 11">
+            <a:extLst>
+              <a:ext uri="{FF2B5EF4-FFF2-40B4-BE49-F238E27FC236}">
+                <a16:creationId xmlns:a16="http://schemas.microsoft.com/office/drawing/2014/main" id="{2704FB8D-0193-78BC-5E43-79A73D9754CB}"/>
+              </a:ext>
+            </a:extLst>
+          </p:cNvPr>
+          <p:cNvSpPr/>
+          <p:nvPr/>
+        </p:nvSpPr>
+        <p:spPr>
+          <a:xfrm>
+            <a:off x="10912928" y="5295447"/>
+            <a:ext cx="881743" cy="1197428"/>
+          </a:xfrm>
+          <a:prstGeom prst="flowChartMagneticDisk">
+            <a:avLst/>
+          </a:prstGeom>
+        </p:spPr>
+        <p:style>
+          <a:lnRef idx="2">
+            <a:schemeClr val="accent1">
+              <a:shade val="15000"/>
+            </a:schemeClr>
+          </a:lnRef>
+          <a:fillRef idx="1">
+            <a:schemeClr val="accent1"/>
+          </a:fillRef>
+          <a:effectRef idx="0">
+            <a:schemeClr val="accent1"/>
+          </a:effectRef>
+          <a:fontRef idx="minor">
+            <a:schemeClr val="lt1"/>
+          </a:fontRef>
+        </p:style>
+        <p:txBody>
+          <a:bodyPr rtlCol="0" anchor="ctr"/>
+          <a:lstStyle/>
+          <a:p>
+            <a:pPr algn="ctr"/>
+            <a:r>
+              <a:rPr lang="en-US" sz="1200" dirty="0"/>
+              <a:t>System State</a:t>
+            </a:r>
+          </a:p>
+        </p:txBody>
+      </p:sp>
+      <p:cxnSp>
+        <p:nvCxnSpPr>
+          <p:cNvPr id="14" name="Straight Arrow Connector 13">
+            <a:extLst>
+              <a:ext uri="{FF2B5EF4-FFF2-40B4-BE49-F238E27FC236}">
+                <a16:creationId xmlns:a16="http://schemas.microsoft.com/office/drawing/2014/main" id="{C7D2DCF9-B3AB-A456-DD96-859DC9A9D426}"/>
+              </a:ext>
+            </a:extLst>
+          </p:cNvPr>
+          <p:cNvCxnSpPr>
+            <a:cxnSpLocks/>
+          </p:cNvCxnSpPr>
+          <p:nvPr/>
+        </p:nvCxnSpPr>
+        <p:spPr>
+          <a:xfrm>
+            <a:off x="11288456" y="4291723"/>
+            <a:ext cx="5443" cy="1003724"/>
+          </a:xfrm>
+          <a:prstGeom prst="straightConnector1">
+            <a:avLst/>
+          </a:prstGeom>
+          <a:ln>
+            <a:tailEnd type="triangle"/>
+          </a:ln>
+        </p:spPr>
+        <p:style>
+          <a:lnRef idx="2">
+            <a:schemeClr val="accent1"/>
+          </a:lnRef>
+          <a:fillRef idx="0">
+            <a:schemeClr val="accent1"/>
+          </a:fillRef>
+          <a:effectRef idx="1">
+            <a:schemeClr val="accent1"/>
+          </a:effectRef>
+          <a:fontRef idx="minor">
+            <a:schemeClr val="tx1"/>
+          </a:fontRef>
+        </p:style>
+      </p:cxnSp>
+      <p:cxnSp>
+        <p:nvCxnSpPr>
+          <p:cNvPr id="15" name="Straight Arrow Connector 14">
+            <a:extLst>
+              <a:ext uri="{FF2B5EF4-FFF2-40B4-BE49-F238E27FC236}">
+                <a16:creationId xmlns:a16="http://schemas.microsoft.com/office/drawing/2014/main" id="{29B37A91-DFF0-718D-9FC3-9060E20AD506}"/>
+              </a:ext>
+            </a:extLst>
+          </p:cNvPr>
+          <p:cNvCxnSpPr>
+            <a:cxnSpLocks/>
+            <a:endCxn id="11" idx="1"/>
+          </p:cNvCxnSpPr>
+          <p:nvPr/>
+        </p:nvCxnSpPr>
+        <p:spPr>
+          <a:xfrm>
+            <a:off x="10403467" y="4291723"/>
+            <a:ext cx="3247" cy="1003724"/>
+          </a:xfrm>
+          <a:prstGeom prst="straightConnector1">
+            <a:avLst/>
+          </a:prstGeom>
+          <a:ln>
+            <a:tailEnd type="triangle"/>
+          </a:ln>
+        </p:spPr>
+        <p:style>
+          <a:lnRef idx="2">
+            <a:schemeClr val="accent1"/>
+          </a:lnRef>
+          <a:fillRef idx="0">
+            <a:schemeClr val="accent1"/>
+          </a:fillRef>
+          <a:effectRef idx="1">
+            <a:schemeClr val="accent1"/>
+          </a:effectRef>
+          <a:fontRef idx="minor">
+            <a:schemeClr val="tx1"/>
+          </a:fontRef>
+        </p:style>
+      </p:cxnSp>
+      <p:cxnSp>
+        <p:nvCxnSpPr>
+          <p:cNvPr id="18" name="Straight Arrow Connector 17">
+            <a:extLst>
+              <a:ext uri="{FF2B5EF4-FFF2-40B4-BE49-F238E27FC236}">
+                <a16:creationId xmlns:a16="http://schemas.microsoft.com/office/drawing/2014/main" id="{BA9E60F9-8C18-4DC6-0A93-577BD0BD71CB}"/>
+              </a:ext>
+            </a:extLst>
+          </p:cNvPr>
+          <p:cNvCxnSpPr>
+            <a:cxnSpLocks/>
+            <a:stCxn id="31" idx="2"/>
+            <a:endCxn id="10" idx="1"/>
+          </p:cNvCxnSpPr>
+          <p:nvPr/>
+        </p:nvCxnSpPr>
+        <p:spPr>
+          <a:xfrm flipH="1">
+            <a:off x="8724877" y="4297360"/>
+            <a:ext cx="1" cy="998087"/>
+          </a:xfrm>
+          <a:prstGeom prst="straightConnector1">
+            <a:avLst/>
+          </a:prstGeom>
+          <a:ln>
+            <a:tailEnd type="triangle"/>
+          </a:ln>
+        </p:spPr>
+        <p:style>
+          <a:lnRef idx="2">
+            <a:schemeClr val="accent1"/>
+          </a:lnRef>
+          <a:fillRef idx="0">
+            <a:schemeClr val="accent1"/>
+          </a:fillRef>
+          <a:effectRef idx="1">
+            <a:schemeClr val="accent1"/>
+          </a:effectRef>
+          <a:fontRef idx="minor">
+            <a:schemeClr val="tx1"/>
+          </a:fontRef>
+        </p:style>
+      </p:cxnSp>
+      <p:cxnSp>
+        <p:nvCxnSpPr>
+          <p:cNvPr id="22" name="Straight Arrow Connector 21">
+            <a:extLst>
+              <a:ext uri="{FF2B5EF4-FFF2-40B4-BE49-F238E27FC236}">
+                <a16:creationId xmlns:a16="http://schemas.microsoft.com/office/drawing/2014/main" id="{700A19D5-7812-C9AD-7AA1-5AE6177514C4}"/>
+              </a:ext>
+            </a:extLst>
+          </p:cNvPr>
+          <p:cNvCxnSpPr>
+            <a:cxnSpLocks/>
+          </p:cNvCxnSpPr>
+          <p:nvPr/>
+        </p:nvCxnSpPr>
+        <p:spPr>
+          <a:xfrm>
+            <a:off x="6664804" y="4158343"/>
+            <a:ext cx="0" cy="1137104"/>
+          </a:xfrm>
+          <a:prstGeom prst="straightConnector1">
+            <a:avLst/>
+          </a:prstGeom>
+          <a:ln>
+            <a:tailEnd type="triangle"/>
+          </a:ln>
+        </p:spPr>
+        <p:style>
+          <a:lnRef idx="2">
+            <a:schemeClr val="accent1"/>
+          </a:lnRef>
+          <a:fillRef idx="0">
+            <a:schemeClr val="accent1"/>
+          </a:fillRef>
+          <a:effectRef idx="1">
+            <a:schemeClr val="accent1"/>
+          </a:effectRef>
+          <a:fontRef idx="minor">
+            <a:schemeClr val="tx1"/>
+          </a:fontRef>
+        </p:style>
+      </p:cxnSp>
+      <p:cxnSp>
+        <p:nvCxnSpPr>
+          <p:cNvPr id="25" name="Straight Arrow Connector 24">
+            <a:extLst>
+              <a:ext uri="{FF2B5EF4-FFF2-40B4-BE49-F238E27FC236}">
+                <a16:creationId xmlns:a16="http://schemas.microsoft.com/office/drawing/2014/main" id="{866EFDDA-F354-B1F3-8CC8-3B7E0878B794}"/>
+              </a:ext>
+            </a:extLst>
+          </p:cNvPr>
+          <p:cNvCxnSpPr>
+            <a:cxnSpLocks/>
+            <a:stCxn id="7" idx="2"/>
+          </p:cNvCxnSpPr>
+          <p:nvPr/>
+        </p:nvCxnSpPr>
+        <p:spPr>
+          <a:xfrm flipH="1">
+            <a:off x="4906757" y="4297362"/>
+            <a:ext cx="8135" cy="998085"/>
+          </a:xfrm>
+          <a:prstGeom prst="straightConnector1">
+            <a:avLst/>
+          </a:prstGeom>
+          <a:ln>
+            <a:tailEnd type="triangle"/>
+          </a:ln>
+        </p:spPr>
+        <p:style>
+          <a:lnRef idx="2">
+            <a:schemeClr val="accent1"/>
+          </a:lnRef>
+          <a:fillRef idx="0">
+            <a:schemeClr val="accent1"/>
+          </a:fillRef>
+          <a:effectRef idx="1">
+            <a:schemeClr val="accent1"/>
+          </a:effectRef>
+          <a:fontRef idx="minor">
+            <a:schemeClr val="tx1"/>
+          </a:fontRef>
+        </p:style>
+      </p:cxnSp>
+      <p:cxnSp>
+        <p:nvCxnSpPr>
+          <p:cNvPr id="30" name="Connector: Elbow 29">
+            <a:extLst>
+              <a:ext uri="{FF2B5EF4-FFF2-40B4-BE49-F238E27FC236}">
+                <a16:creationId xmlns:a16="http://schemas.microsoft.com/office/drawing/2014/main" id="{55327C8A-5A62-BF56-A14B-06A145AEAE81}"/>
+              </a:ext>
+            </a:extLst>
+          </p:cNvPr>
+          <p:cNvCxnSpPr>
+            <a:cxnSpLocks/>
+            <a:endCxn id="6" idx="2"/>
+          </p:cNvCxnSpPr>
+          <p:nvPr/>
+        </p:nvCxnSpPr>
+        <p:spPr>
+          <a:xfrm rot="10800000" flipV="1">
+            <a:off x="3009899" y="4297359"/>
+            <a:ext cx="1684544" cy="684"/>
+          </a:xfrm>
+          <a:prstGeom prst="bentConnector4">
+            <a:avLst>
+              <a:gd name="adj1" fmla="val 26252"/>
+              <a:gd name="adj2" fmla="val 33521053"/>
+            </a:avLst>
+          </a:prstGeom>
+          <a:ln>
+            <a:tailEnd type="triangle"/>
+          </a:ln>
+        </p:spPr>
+        <p:style>
+          <a:lnRef idx="2">
+            <a:schemeClr val="accent1"/>
+          </a:lnRef>
+          <a:fillRef idx="0">
+            <a:schemeClr val="accent1"/>
+          </a:fillRef>
+          <a:effectRef idx="1">
+            <a:schemeClr val="accent1"/>
+          </a:effectRef>
+          <a:fontRef idx="minor">
+            <a:schemeClr val="tx1"/>
+          </a:fontRef>
+        </p:style>
+      </p:cxnSp>
+      <p:cxnSp>
+        <p:nvCxnSpPr>
+          <p:cNvPr id="37" name="Straight Arrow Connector 36">
+            <a:extLst>
+              <a:ext uri="{FF2B5EF4-FFF2-40B4-BE49-F238E27FC236}">
+                <a16:creationId xmlns:a16="http://schemas.microsoft.com/office/drawing/2014/main" id="{F6913B19-0065-B9C4-020F-E94F52EEC1E9}"/>
+              </a:ext>
+            </a:extLst>
+          </p:cNvPr>
+          <p:cNvCxnSpPr>
+            <a:cxnSpLocks/>
+          </p:cNvCxnSpPr>
+          <p:nvPr/>
+        </p:nvCxnSpPr>
+        <p:spPr>
+          <a:xfrm flipH="1">
+            <a:off x="2082388" y="4321519"/>
+            <a:ext cx="212579" cy="968289"/>
+          </a:xfrm>
+          <a:prstGeom prst="straightConnector1">
+            <a:avLst/>
+          </a:prstGeom>
+          <a:ln>
+            <a:tailEnd type="triangle"/>
+          </a:ln>
+        </p:spPr>
+        <p:style>
+          <a:lnRef idx="2">
+            <a:schemeClr val="accent1"/>
+          </a:lnRef>
+          <a:fillRef idx="0">
+            <a:schemeClr val="accent1"/>
+          </a:fillRef>
+          <a:effectRef idx="1">
+            <a:schemeClr val="accent1"/>
+          </a:effectRef>
+          <a:fontRef idx="minor">
+            <a:schemeClr val="tx1"/>
+          </a:fontRef>
+        </p:style>
+      </p:cxnSp>
+      <p:cxnSp>
+        <p:nvCxnSpPr>
+          <p:cNvPr id="38" name="Connector: Elbow 37">
+            <a:extLst>
+              <a:ext uri="{FF2B5EF4-FFF2-40B4-BE49-F238E27FC236}">
+                <a16:creationId xmlns:a16="http://schemas.microsoft.com/office/drawing/2014/main" id="{3BB11F8B-060F-5420-80B7-319EDAFCC0B4}"/>
+              </a:ext>
+            </a:extLst>
+          </p:cNvPr>
+          <p:cNvCxnSpPr>
+            <a:cxnSpLocks/>
+          </p:cNvCxnSpPr>
+          <p:nvPr/>
+        </p:nvCxnSpPr>
+        <p:spPr>
+          <a:xfrm rot="5400000" flipH="1">
+            <a:off x="1870235" y="3259688"/>
+            <a:ext cx="4214" cy="2068284"/>
+          </a:xfrm>
+          <a:prstGeom prst="bentConnector3">
+            <a:avLst>
+              <a:gd name="adj1" fmla="val -5424775"/>
+            </a:avLst>
+          </a:prstGeom>
+          <a:ln>
+            <a:tailEnd type="triangle"/>
+          </a:ln>
+        </p:spPr>
+        <p:style>
+          <a:lnRef idx="2">
+            <a:schemeClr val="accent1"/>
+          </a:lnRef>
+          <a:fillRef idx="0">
+            <a:schemeClr val="accent1"/>
+          </a:fillRef>
+          <a:effectRef idx="1">
+            <a:schemeClr val="accent1"/>
+          </a:effectRef>
+          <a:fontRef idx="minor">
+            <a:schemeClr val="tx1"/>
+          </a:fontRef>
+        </p:style>
+      </p:cxnSp>
+      <p:sp>
+        <p:nvSpPr>
+          <p:cNvPr id="45" name="TextBox 44">
+            <a:extLst>
+              <a:ext uri="{FF2B5EF4-FFF2-40B4-BE49-F238E27FC236}">
+                <a16:creationId xmlns:a16="http://schemas.microsoft.com/office/drawing/2014/main" id="{75D397CF-66FD-A250-782F-B3FA4FD10CA7}"/>
+              </a:ext>
+            </a:extLst>
+          </p:cNvPr>
+          <p:cNvSpPr txBox="1"/>
+          <p:nvPr/>
+        </p:nvSpPr>
+        <p:spPr>
+          <a:xfrm>
+            <a:off x="7390159" y="4517241"/>
+            <a:ext cx="2613262" cy="276999"/>
+          </a:xfrm>
+          <a:prstGeom prst="rect">
+            <a:avLst/>
+          </a:prstGeom>
+          <a:noFill/>
+        </p:spPr>
+        <p:txBody>
+          <a:bodyPr wrap="square" rtlCol="0">
+            <a:spAutoFit/>
+          </a:bodyPr>
+          <a:lstStyle/>
+          <a:p>
+            <a:pPr algn="ctr"/>
+            <a:r>
+              <a:rPr lang="en-US" sz="1200" b="1" dirty="0"/>
+              <a:t>Update Portfolio With Trade Data</a:t>
+            </a:r>
+          </a:p>
+        </p:txBody>
+      </p:sp>
+      <p:sp>
+        <p:nvSpPr>
+          <p:cNvPr id="46" name="TextBox 45">
+            <a:extLst>
+              <a:ext uri="{FF2B5EF4-FFF2-40B4-BE49-F238E27FC236}">
+                <a16:creationId xmlns:a16="http://schemas.microsoft.com/office/drawing/2014/main" id="{846A9C87-BAF7-6C58-FDBB-76643FECE10B}"/>
+              </a:ext>
+            </a:extLst>
+          </p:cNvPr>
+          <p:cNvSpPr txBox="1"/>
+          <p:nvPr/>
+        </p:nvSpPr>
+        <p:spPr>
+          <a:xfrm>
+            <a:off x="2602802" y="4482285"/>
+            <a:ext cx="1629483" cy="830997"/>
+          </a:xfrm>
+          <a:prstGeom prst="rect">
+            <a:avLst/>
+          </a:prstGeom>
+          <a:noFill/>
+        </p:spPr>
+        <p:txBody>
+          <a:bodyPr wrap="square" rtlCol="0">
+            <a:spAutoFit/>
+          </a:bodyPr>
+          <a:lstStyle/>
+          <a:p>
+            <a:pPr algn="ctr"/>
+            <a:r>
+              <a:rPr lang="en-US" sz="1200" b="1" dirty="0"/>
+              <a:t>Strategy Tells Data Service New Symbols to include in Universe</a:t>
+            </a:r>
+          </a:p>
+        </p:txBody>
+      </p:sp>
+      <p:sp>
+        <p:nvSpPr>
+          <p:cNvPr id="47" name="TextBox 46">
+            <a:extLst>
+              <a:ext uri="{FF2B5EF4-FFF2-40B4-BE49-F238E27FC236}">
+                <a16:creationId xmlns:a16="http://schemas.microsoft.com/office/drawing/2014/main" id="{E471EF7F-FEBC-5BC0-A889-27CED8E6FB48}"/>
+              </a:ext>
+            </a:extLst>
+          </p:cNvPr>
+          <p:cNvSpPr txBox="1"/>
+          <p:nvPr/>
+        </p:nvSpPr>
+        <p:spPr>
+          <a:xfrm>
+            <a:off x="274297" y="4517241"/>
+            <a:ext cx="1684545" cy="646331"/>
+          </a:xfrm>
+          <a:prstGeom prst="rect">
+            <a:avLst/>
+          </a:prstGeom>
+          <a:noFill/>
+        </p:spPr>
+        <p:txBody>
+          <a:bodyPr wrap="square" rtlCol="0">
+            <a:spAutoFit/>
+          </a:bodyPr>
+          <a:lstStyle/>
+          <a:p>
+            <a:pPr algn="ctr"/>
+            <a:r>
+              <a:rPr lang="en-US" sz="1200" b="1" dirty="0"/>
+              <a:t>Universe Tell Fetcher which Symbols to pull data for</a:t>
+            </a:r>
+          </a:p>
+        </p:txBody>
+      </p:sp>
+      <p:cxnSp>
+        <p:nvCxnSpPr>
+          <p:cNvPr id="48" name="Straight Arrow Connector 47">
+            <a:extLst>
+              <a:ext uri="{FF2B5EF4-FFF2-40B4-BE49-F238E27FC236}">
+                <a16:creationId xmlns:a16="http://schemas.microsoft.com/office/drawing/2014/main" id="{3DC9F897-BFC0-A9EE-AAFD-BB0715D343DA}"/>
+              </a:ext>
+            </a:extLst>
+          </p:cNvPr>
+          <p:cNvCxnSpPr>
+            <a:cxnSpLocks/>
+          </p:cNvCxnSpPr>
+          <p:nvPr/>
+        </p:nvCxnSpPr>
+        <p:spPr>
+          <a:xfrm flipH="1">
+            <a:off x="2735978" y="4306620"/>
+            <a:ext cx="8135" cy="998085"/>
+          </a:xfrm>
+          <a:prstGeom prst="straightConnector1">
+            <a:avLst/>
+          </a:prstGeom>
+          <a:ln>
+            <a:tailEnd type="triangle"/>
+          </a:ln>
+        </p:spPr>
+        <p:style>
+          <a:lnRef idx="2">
+            <a:schemeClr val="accent1"/>
+          </a:lnRef>
+          <a:fillRef idx="0">
+            <a:schemeClr val="accent1"/>
+          </a:fillRef>
+          <a:effectRef idx="1">
+            <a:schemeClr val="accent1"/>
+          </a:effectRef>
+          <a:fontRef idx="minor">
+            <a:schemeClr val="tx1"/>
+          </a:fontRef>
+        </p:style>
+      </p:cxnSp>
+      <p:cxnSp>
+        <p:nvCxnSpPr>
+          <p:cNvPr id="52" name="Straight Arrow Connector 51">
+            <a:extLst>
+              <a:ext uri="{FF2B5EF4-FFF2-40B4-BE49-F238E27FC236}">
+                <a16:creationId xmlns:a16="http://schemas.microsoft.com/office/drawing/2014/main" id="{9575CC41-C698-D441-E6FD-352DFBB1DDF6}"/>
+              </a:ext>
+            </a:extLst>
+          </p:cNvPr>
+          <p:cNvCxnSpPr>
+            <a:cxnSpLocks/>
+          </p:cNvCxnSpPr>
+          <p:nvPr/>
+        </p:nvCxnSpPr>
+        <p:spPr>
+          <a:xfrm>
+            <a:off x="11429971" y="3426299"/>
+            <a:ext cx="762029" cy="0"/>
+          </a:xfrm>
+          <a:prstGeom prst="straightConnector1">
+            <a:avLst/>
+          </a:prstGeom>
+          <a:ln>
+            <a:tailEnd type="triangle"/>
+          </a:ln>
+        </p:spPr>
+        <p:style>
+          <a:lnRef idx="2">
+            <a:schemeClr val="accent1"/>
+          </a:lnRef>
+          <a:fillRef idx="0">
+            <a:schemeClr val="accent1"/>
+          </a:fillRef>
+          <a:effectRef idx="1">
+            <a:schemeClr val="accent1"/>
+          </a:effectRef>
+          <a:fontRef idx="minor">
+            <a:schemeClr val="tx1"/>
+          </a:fontRef>
+        </p:style>
+      </p:cxnSp>
+      <p:cxnSp>
+        <p:nvCxnSpPr>
+          <p:cNvPr id="56" name="Straight Arrow Connector 55">
+            <a:extLst>
+              <a:ext uri="{FF2B5EF4-FFF2-40B4-BE49-F238E27FC236}">
+                <a16:creationId xmlns:a16="http://schemas.microsoft.com/office/drawing/2014/main" id="{43988A4E-3C03-04C7-C7A3-10BF3DD25BCA}"/>
+              </a:ext>
+            </a:extLst>
+          </p:cNvPr>
+          <p:cNvCxnSpPr>
+            <a:cxnSpLocks/>
+          </p:cNvCxnSpPr>
+          <p:nvPr/>
+        </p:nvCxnSpPr>
+        <p:spPr>
+          <a:xfrm flipH="1">
+            <a:off x="11449216" y="3640900"/>
+            <a:ext cx="690909" cy="0"/>
+          </a:xfrm>
+          <a:prstGeom prst="straightConnector1">
+            <a:avLst/>
+          </a:prstGeom>
+          <a:ln>
+            <a:tailEnd type="triangle"/>
+          </a:ln>
+        </p:spPr>
+        <p:style>
+          <a:lnRef idx="2">
+            <a:schemeClr val="accent1"/>
+          </a:lnRef>
+          <a:fillRef idx="0">
+            <a:schemeClr val="accent1"/>
+          </a:fillRef>
+          <a:effectRef idx="1">
+            <a:schemeClr val="accent1"/>
+          </a:effectRef>
+          <a:fontRef idx="minor">
+            <a:schemeClr val="tx1"/>
+          </a:fontRef>
+        </p:style>
+      </p:cxnSp>
+      <p:sp>
+        <p:nvSpPr>
+          <p:cNvPr id="69" name="TextBox 68">
+            <a:extLst>
+              <a:ext uri="{FF2B5EF4-FFF2-40B4-BE49-F238E27FC236}">
+                <a16:creationId xmlns:a16="http://schemas.microsoft.com/office/drawing/2014/main" id="{358BED4E-70EA-91ED-4F7C-F957EBC87095}"/>
+              </a:ext>
+            </a:extLst>
+          </p:cNvPr>
+          <p:cNvSpPr txBox="1"/>
+          <p:nvPr/>
+        </p:nvSpPr>
+        <p:spPr>
+          <a:xfrm>
+            <a:off x="11287863" y="3094295"/>
+            <a:ext cx="1046246" cy="276999"/>
+          </a:xfrm>
+          <a:prstGeom prst="rect">
+            <a:avLst/>
+          </a:prstGeom>
+          <a:noFill/>
+        </p:spPr>
+        <p:txBody>
+          <a:bodyPr wrap="square" rtlCol="0">
+            <a:spAutoFit/>
+          </a:bodyPr>
+          <a:lstStyle/>
+          <a:p>
+            <a:pPr algn="ctr"/>
+            <a:r>
+              <a:rPr lang="en-US" sz="1200" b="1" dirty="0"/>
+              <a:t>Trade Data</a:t>
+            </a:r>
+          </a:p>
+        </p:txBody>
+      </p:sp>
+      <p:sp>
+        <p:nvSpPr>
+          <p:cNvPr id="71" name="TextBox 70">
+            <a:extLst>
+              <a:ext uri="{FF2B5EF4-FFF2-40B4-BE49-F238E27FC236}">
+                <a16:creationId xmlns:a16="http://schemas.microsoft.com/office/drawing/2014/main" id="{B733FFBE-689C-A39D-F664-201AF40F8DCE}"/>
+              </a:ext>
+            </a:extLst>
+          </p:cNvPr>
+          <p:cNvSpPr txBox="1"/>
+          <p:nvPr/>
+        </p:nvSpPr>
+        <p:spPr>
+          <a:xfrm>
+            <a:off x="11287863" y="3648344"/>
+            <a:ext cx="1046246" cy="276999"/>
+          </a:xfrm>
+          <a:prstGeom prst="rect">
+            <a:avLst/>
+          </a:prstGeom>
+          <a:noFill/>
+        </p:spPr>
+        <p:txBody>
+          <a:bodyPr wrap="square" rtlCol="0">
+            <a:spAutoFit/>
+          </a:bodyPr>
+          <a:lstStyle/>
+          <a:p>
+            <a:pPr algn="ctr"/>
+            <a:r>
+              <a:rPr lang="en-US" sz="1200" b="1" dirty="0"/>
+              <a:t>Response</a:t>
+            </a:r>
+          </a:p>
+        </p:txBody>
+      </p:sp>
+      <p:sp>
+        <p:nvSpPr>
+          <p:cNvPr id="73" name="TextBox 72">
+            <a:extLst>
+              <a:ext uri="{FF2B5EF4-FFF2-40B4-BE49-F238E27FC236}">
+                <a16:creationId xmlns:a16="http://schemas.microsoft.com/office/drawing/2014/main" id="{6777B6CC-A76A-FAF8-4F50-E1CC8E4B5B67}"/>
+              </a:ext>
+            </a:extLst>
+          </p:cNvPr>
+          <p:cNvSpPr txBox="1"/>
+          <p:nvPr/>
+        </p:nvSpPr>
+        <p:spPr>
+          <a:xfrm>
+            <a:off x="4237254" y="1763809"/>
+            <a:ext cx="1328057" cy="461665"/>
+          </a:xfrm>
+          <a:prstGeom prst="rect">
+            <a:avLst/>
+          </a:prstGeom>
+          <a:noFill/>
+        </p:spPr>
+        <p:txBody>
+          <a:bodyPr wrap="square" rtlCol="0">
+            <a:spAutoFit/>
+          </a:bodyPr>
+          <a:lstStyle/>
+          <a:p>
+            <a:pPr algn="ctr"/>
+            <a:r>
+              <a:rPr lang="en-US" sz="2400" b="1" dirty="0"/>
+              <a:t>Brain</a:t>
+            </a:r>
+            <a:endParaRPr lang="en-US" b="1" dirty="0"/>
+          </a:p>
+        </p:txBody>
+      </p:sp>
+      <p:sp>
+        <p:nvSpPr>
+          <p:cNvPr id="75" name="Rectangle: Rounded Corners 74">
+            <a:extLst>
+              <a:ext uri="{FF2B5EF4-FFF2-40B4-BE49-F238E27FC236}">
+                <a16:creationId xmlns:a16="http://schemas.microsoft.com/office/drawing/2014/main" id="{CFC72D17-0CE5-1E09-66BD-FCCDCB2FBA05}"/>
+              </a:ext>
+            </a:extLst>
+          </p:cNvPr>
+          <p:cNvSpPr/>
+          <p:nvPr/>
+        </p:nvSpPr>
+        <p:spPr>
+          <a:xfrm>
+            <a:off x="4036403" y="2225474"/>
+            <a:ext cx="1814652" cy="4367004"/>
+          </a:xfrm>
+          <a:prstGeom prst="roundRect">
+            <a:avLst/>
+          </a:prstGeom>
+          <a:noFill/>
+        </p:spPr>
+        <p:style>
+          <a:lnRef idx="2">
+            <a:schemeClr val="accent1">
+              <a:shade val="15000"/>
+            </a:schemeClr>
+          </a:lnRef>
+          <a:fillRef idx="1">
+            <a:schemeClr val="accent1"/>
+          </a:fillRef>
+          <a:effectRef idx="0">
+            <a:schemeClr val="accent1"/>
+          </a:effectRef>
+          <a:fontRef idx="minor">
+            <a:schemeClr val="lt1"/>
+          </a:fontRef>
+        </p:style>
+        <p:txBody>
+          <a:bodyPr rtlCol="0" anchor="ctr"/>
+          <a:lstStyle/>
+          <a:p>
+            <a:pPr algn="ctr"/>
+            <a:endParaRPr lang="en-US"/>
+          </a:p>
+        </p:txBody>
+      </p:sp>
     </p:spTree>
     <p:extLst>
       <p:ext uri="{BB962C8B-B14F-4D97-AF65-F5344CB8AC3E}">
@@ -5990,4 +7451,319 @@
     </a:ext>
   </a:extLst>
 </a:theme>
+</file>
+
+<file path=ppt/theme/theme2.xml><?xml version="1.0" encoding="utf-8"?>
+<a:theme xmlns:a="http://schemas.openxmlformats.org/drawingml/2006/main" name="Office Theme">
+  <a:themeElements>
+    <a:clrScheme name="Office">
+      <a:dk1>
+        <a:sysClr val="windowText" lastClr="000000"/>
+      </a:dk1>
+      <a:lt1>
+        <a:sysClr val="window" lastClr="FFFFFF"/>
+      </a:lt1>
+      <a:dk2>
+        <a:srgbClr val="0E2841"/>
+      </a:dk2>
+      <a:lt2>
+        <a:srgbClr val="E8E8E8"/>
+      </a:lt2>
+      <a:accent1>
+        <a:srgbClr val="156082"/>
+      </a:accent1>
+      <a:accent2>
+        <a:srgbClr val="E97132"/>
+      </a:accent2>
+      <a:accent3>
+        <a:srgbClr val="196B24"/>
+      </a:accent3>
+      <a:accent4>
+        <a:srgbClr val="0F9ED5"/>
+      </a:accent4>
+      <a:accent5>
+        <a:srgbClr val="A02B93"/>
+      </a:accent5>
+      <a:accent6>
+        <a:srgbClr val="4EA72E"/>
+      </a:accent6>
+      <a:hlink>
+        <a:srgbClr val="467886"/>
+      </a:hlink>
+      <a:folHlink>
+        <a:srgbClr val="96607D"/>
+      </a:folHlink>
+    </a:clrScheme>
+    <a:fontScheme name="Office">
+      <a:majorFont>
+        <a:latin typeface="Aptos Display" panose="02110004020202020204"/>
+        <a:ea typeface=""/>
+        <a:cs typeface=""/>
+        <a:font script="Jpan" typeface="游ゴシック Light"/>
+        <a:font script="Hang" typeface="맑은 고딕"/>
+        <a:font script="Hans" typeface="等线 Light"/>
+        <a:font script="Hant" typeface="新細明體"/>
+        <a:font script="Arab" typeface="Times New Roman"/>
+        <a:font script="Hebr" typeface="Times New Roman"/>
+        <a:font script="Thai" typeface="Angsana New"/>
+        <a:font script="Ethi" typeface="Nyala"/>
+        <a:font script="Beng" typeface="Vrinda"/>
+        <a:font script="Gujr" typeface="Shruti"/>
+        <a:font script="Khmr" typeface="MoolBoran"/>
+        <a:font script="Knda" typeface="Tunga"/>
+        <a:font script="Guru" typeface="Raavi"/>
+        <a:font script="Cans" typeface="Euphemia"/>
+        <a:font script="Cher" typeface="Plantagenet Cherokee"/>
+        <a:font script="Yiii" typeface="Microsoft Yi Baiti"/>
+        <a:font script="Tibt" typeface="Microsoft Himalaya"/>
+        <a:font script="Thaa" typeface="MV Boli"/>
+        <a:font script="Deva" typeface="Mangal"/>
+        <a:font script="Telu" typeface="Gautami"/>
+        <a:font script="Taml" typeface="Latha"/>
+        <a:font script="Syrc" typeface="Estrangelo Edessa"/>
+        <a:font script="Orya" typeface="Kalinga"/>
+        <a:font script="Mlym" typeface="Kartika"/>
+        <a:font script="Laoo" typeface="DokChampa"/>
+        <a:font script="Sinh" typeface="Iskoola Pota"/>
+        <a:font script="Mong" typeface="Mongolian Baiti"/>
+        <a:font script="Viet" typeface="Times New Roman"/>
+        <a:font script="Uigh" typeface="Microsoft Uighur"/>
+        <a:font script="Geor" typeface="Sylfaen"/>
+        <a:font script="Armn" typeface="Arial"/>
+        <a:font script="Bugi" typeface="Leelawadee UI"/>
+        <a:font script="Bopo" typeface="Microsoft JhengHei"/>
+        <a:font script="Java" typeface="Javanese Text"/>
+        <a:font script="Lisu" typeface="Segoe UI"/>
+        <a:font script="Mymr" typeface="Myanmar Text"/>
+        <a:font script="Nkoo" typeface="Ebrima"/>
+        <a:font script="Olck" typeface="Nirmala UI"/>
+        <a:font script="Osma" typeface="Ebrima"/>
+        <a:font script="Phag" typeface="Phagspa"/>
+        <a:font script="Syrn" typeface="Estrangelo Edessa"/>
+        <a:font script="Syrj" typeface="Estrangelo Edessa"/>
+        <a:font script="Syre" typeface="Estrangelo Edessa"/>
+        <a:font script="Sora" typeface="Nirmala UI"/>
+        <a:font script="Tale" typeface="Microsoft Tai Le"/>
+        <a:font script="Talu" typeface="Microsoft New Tai Lue"/>
+        <a:font script="Tfng" typeface="Ebrima"/>
+      </a:majorFont>
+      <a:minorFont>
+        <a:latin typeface="Aptos" panose="02110004020202020204"/>
+        <a:ea typeface=""/>
+        <a:cs typeface=""/>
+        <a:font script="Jpan" typeface="游ゴシック"/>
+        <a:font script="Hang" typeface="맑은 고딕"/>
+        <a:font script="Hans" typeface="等线"/>
+        <a:font script="Hant" typeface="新細明體"/>
+        <a:font script="Arab" typeface="Arial"/>
+        <a:font script="Hebr" typeface="Arial"/>
+        <a:font script="Thai" typeface="Cordia New"/>
+        <a:font script="Ethi" typeface="Nyala"/>
+        <a:font script="Beng" typeface="Vrinda"/>
+        <a:font script="Gujr" typeface="Shruti"/>
+        <a:font script="Khmr" typeface="DaunPenh"/>
+        <a:font script="Knda" typeface="Tunga"/>
+        <a:font script="Guru" typeface="Raavi"/>
+        <a:font script="Cans" typeface="Euphemia"/>
+        <a:font script="Cher" typeface="Plantagenet Cherokee"/>
+        <a:font script="Yiii" typeface="Microsoft Yi Baiti"/>
+        <a:font script="Tibt" typeface="Microsoft Himalaya"/>
+        <a:font script="Thaa" typeface="MV Boli"/>
+        <a:font script="Deva" typeface="Mangal"/>
+        <a:font script="Telu" typeface="Gautami"/>
+        <a:font script="Taml" typeface="Latha"/>
+        <a:font script="Syrc" typeface="Estrangelo Edessa"/>
+        <a:font script="Orya" typeface="Kalinga"/>
+        <a:font script="Mlym" typeface="Kartika"/>
+        <a:font script="Laoo" typeface="DokChampa"/>
+        <a:font script="Sinh" typeface="Iskoola Pota"/>
+        <a:font script="Mong" typeface="Mongolian Baiti"/>
+        <a:font script="Viet" typeface="Arial"/>
+        <a:font script="Uigh" typeface="Microsoft Uighur"/>
+        <a:font script="Geor" typeface="Sylfaen"/>
+        <a:font script="Armn" typeface="Arial"/>
+        <a:font script="Bugi" typeface="Leelawadee UI"/>
+        <a:font script="Bopo" typeface="Microsoft JhengHei"/>
+        <a:font script="Java" typeface="Javanese Text"/>
+        <a:font script="Lisu" typeface="Segoe UI"/>
+        <a:font script="Mymr" typeface="Myanmar Text"/>
+        <a:font script="Nkoo" typeface="Ebrima"/>
+        <a:font script="Olck" typeface="Nirmala UI"/>
+        <a:font script="Osma" typeface="Ebrima"/>
+        <a:font script="Phag" typeface="Phagspa"/>
+        <a:font script="Syrn" typeface="Estrangelo Edessa"/>
+        <a:font script="Syrj" typeface="Estrangelo Edessa"/>
+        <a:font script="Syre" typeface="Estrangelo Edessa"/>
+        <a:font script="Sora" typeface="Nirmala UI"/>
+        <a:font script="Tale" typeface="Microsoft Tai Le"/>
+        <a:font script="Talu" typeface="Microsoft New Tai Lue"/>
+        <a:font script="Tfng" typeface="Ebrima"/>
+      </a:minorFont>
+    </a:fontScheme>
+    <a:fmtScheme name="Office">
+      <a:fillStyleLst>
+        <a:solidFill>
+          <a:schemeClr val="phClr"/>
+        </a:solidFill>
+        <a:gradFill rotWithShape="1">
+          <a:gsLst>
+            <a:gs pos="0">
+              <a:schemeClr val="phClr">
+                <a:lumMod val="110000"/>
+                <a:satMod val="105000"/>
+                <a:tint val="67000"/>
+              </a:schemeClr>
+            </a:gs>
+            <a:gs pos="50000">
+              <a:schemeClr val="phClr">
+                <a:lumMod val="105000"/>
+                <a:satMod val="103000"/>
+                <a:tint val="73000"/>
+              </a:schemeClr>
+            </a:gs>
+            <a:gs pos="100000">
+              <a:schemeClr val="phClr">
+                <a:lumMod val="105000"/>
+                <a:satMod val="109000"/>
+                <a:tint val="81000"/>
+              </a:schemeClr>
+            </a:gs>
+          </a:gsLst>
+          <a:lin ang="5400000" scaled="0"/>
+        </a:gradFill>
+        <a:gradFill rotWithShape="1">
+          <a:gsLst>
+            <a:gs pos="0">
+              <a:schemeClr val="phClr">
+                <a:satMod val="103000"/>
+                <a:lumMod val="102000"/>
+                <a:tint val="94000"/>
+              </a:schemeClr>
+            </a:gs>
+            <a:gs pos="50000">
+              <a:schemeClr val="phClr">
+                <a:satMod val="110000"/>
+                <a:lumMod val="100000"/>
+                <a:shade val="100000"/>
+              </a:schemeClr>
+            </a:gs>
+            <a:gs pos="100000">
+              <a:schemeClr val="phClr">
+                <a:lumMod val="99000"/>
+                <a:satMod val="120000"/>
+                <a:shade val="78000"/>
+              </a:schemeClr>
+            </a:gs>
+          </a:gsLst>
+          <a:lin ang="5400000" scaled="0"/>
+        </a:gradFill>
+      </a:fillStyleLst>
+      <a:lnStyleLst>
+        <a:ln w="12700" cap="flat" cmpd="sng" algn="ctr">
+          <a:solidFill>
+            <a:schemeClr val="phClr"/>
+          </a:solidFill>
+          <a:prstDash val="solid"/>
+          <a:miter lim="800000"/>
+        </a:ln>
+        <a:ln w="19050" cap="flat" cmpd="sng" algn="ctr">
+          <a:solidFill>
+            <a:schemeClr val="phClr"/>
+          </a:solidFill>
+          <a:prstDash val="solid"/>
+          <a:miter lim="800000"/>
+        </a:ln>
+        <a:ln w="25400" cap="flat" cmpd="sng" algn="ctr">
+          <a:solidFill>
+            <a:schemeClr val="phClr"/>
+          </a:solidFill>
+          <a:prstDash val="solid"/>
+          <a:miter lim="800000"/>
+        </a:ln>
+      </a:lnStyleLst>
+      <a:effectStyleLst>
+        <a:effectStyle>
+          <a:effectLst/>
+        </a:effectStyle>
+        <a:effectStyle>
+          <a:effectLst/>
+        </a:effectStyle>
+        <a:effectStyle>
+          <a:effectLst>
+            <a:outerShdw blurRad="57150" dist="19050" dir="5400000" algn="ctr" rotWithShape="0">
+              <a:srgbClr val="000000">
+                <a:alpha val="63000"/>
+              </a:srgbClr>
+            </a:outerShdw>
+          </a:effectLst>
+        </a:effectStyle>
+      </a:effectStyleLst>
+      <a:bgFillStyleLst>
+        <a:solidFill>
+          <a:schemeClr val="phClr"/>
+        </a:solidFill>
+        <a:solidFill>
+          <a:schemeClr val="phClr">
+            <a:tint val="95000"/>
+            <a:satMod val="170000"/>
+          </a:schemeClr>
+        </a:solidFill>
+        <a:gradFill rotWithShape="1">
+          <a:gsLst>
+            <a:gs pos="0">
+              <a:schemeClr val="phClr">
+                <a:tint val="93000"/>
+                <a:satMod val="150000"/>
+                <a:shade val="98000"/>
+                <a:lumMod val="102000"/>
+              </a:schemeClr>
+            </a:gs>
+            <a:gs pos="50000">
+              <a:schemeClr val="phClr">
+                <a:tint val="98000"/>
+                <a:satMod val="130000"/>
+                <a:shade val="90000"/>
+                <a:lumMod val="103000"/>
+              </a:schemeClr>
+            </a:gs>
+            <a:gs pos="100000">
+              <a:schemeClr val="phClr">
+                <a:shade val="63000"/>
+                <a:satMod val="120000"/>
+              </a:schemeClr>
+            </a:gs>
+          </a:gsLst>
+          <a:lin ang="5400000" scaled="0"/>
+        </a:gradFill>
+      </a:bgFillStyleLst>
+    </a:fmtScheme>
+  </a:themeElements>
+  <a:objectDefaults>
+    <a:lnDef>
+      <a:spPr/>
+      <a:bodyPr/>
+      <a:lstStyle/>
+      <a:style>
+        <a:lnRef idx="2">
+          <a:schemeClr val="accent1"/>
+        </a:lnRef>
+        <a:fillRef idx="0">
+          <a:schemeClr val="accent1"/>
+        </a:fillRef>
+        <a:effectRef idx="1">
+          <a:schemeClr val="accent1"/>
+        </a:effectRef>
+        <a:fontRef idx="minor">
+          <a:schemeClr val="tx1"/>
+        </a:fontRef>
+      </a:style>
+    </a:lnDef>
+  </a:objectDefaults>
+  <a:extraClrSchemeLst/>
+  <a:extLst>
+    <a:ext uri="{05A4C25C-085E-4340-85A3-A5531E510DB2}">
+      <thm15:themeFamily xmlns:thm15="http://schemas.microsoft.com/office/thememl/2012/main" name="Office Theme" id="{2E142A2C-CD16-42D6-873A-C26D2A0506FA}" vid="{1BDDFF52-6CD6-40A5-AB3C-68EB2F1E4D0A}"/>
+    </a:ext>
+  </a:extLst>
+</a:theme>
 </file>
</xml_diff>

<commit_message>
Add market data streaming service
</commit_message>
<xml_diff>
--- a/00_system_architecture/quant_management_platform_architecture.pptx
+++ b/00_system_architecture/quant_management_platform_architecture.pptx
@@ -5,19 +5,22 @@
     <p:sldMasterId id="2147483648" r:id="rId1"/>
   </p:sldMasterIdLst>
   <p:notesMasterIdLst>
-    <p:notesMasterId r:id="rId12"/>
+    <p:notesMasterId r:id="rId15"/>
   </p:notesMasterIdLst>
   <p:sldIdLst>
     <p:sldId id="256" r:id="rId2"/>
     <p:sldId id="265" r:id="rId3"/>
-    <p:sldId id="258" r:id="rId4"/>
-    <p:sldId id="257" r:id="rId5"/>
-    <p:sldId id="259" r:id="rId6"/>
-    <p:sldId id="260" r:id="rId7"/>
-    <p:sldId id="261" r:id="rId8"/>
-    <p:sldId id="262" r:id="rId9"/>
-    <p:sldId id="263" r:id="rId10"/>
-    <p:sldId id="264" r:id="rId11"/>
+    <p:sldId id="257" r:id="rId4"/>
+    <p:sldId id="258" r:id="rId5"/>
+    <p:sldId id="267" r:id="rId6"/>
+    <p:sldId id="268" r:id="rId7"/>
+    <p:sldId id="259" r:id="rId8"/>
+    <p:sldId id="260" r:id="rId9"/>
+    <p:sldId id="266" r:id="rId10"/>
+    <p:sldId id="261" r:id="rId11"/>
+    <p:sldId id="262" r:id="rId12"/>
+    <p:sldId id="263" r:id="rId13"/>
+    <p:sldId id="264" r:id="rId14"/>
   </p:sldIdLst>
   <p:sldSz cx="12192000" cy="6858000"/>
   <p:notesSz cx="6858000" cy="9144000"/>
@@ -206,7 +209,7 @@
           <a:p>
             <a:fld id="{70866825-8C01-4766-8F79-C41ECFD9525D}" type="datetimeFigureOut">
               <a:rPr lang="en-US" smtClean="0"/>
-              <a:t>12/30/2025</a:t>
+              <a:t>1/20/2026</a:t>
             </a:fld>
             <a:endParaRPr lang="en-US"/>
           </a:p>
@@ -538,7 +541,7 @@
           <a:p>
             <a:fld id="{1A238C5B-EE31-4EFC-BE39-0EEC656BD8F3}" type="slidenum">
               <a:rPr lang="en-US" smtClean="0"/>
-              <a:t>4</a:t>
+              <a:t>3</a:t>
             </a:fld>
             <a:endParaRPr lang="en-US"/>
           </a:p>
@@ -704,7 +707,7 @@
           <a:p>
             <a:fld id="{7CD6D201-3712-4708-B8BD-34638CB62F40}" type="datetimeFigureOut">
               <a:rPr lang="en-US" smtClean="0"/>
-              <a:t>12/30/2025</a:t>
+              <a:t>1/20/2026</a:t>
             </a:fld>
             <a:endParaRPr lang="en-US"/>
           </a:p>
@@ -902,7 +905,7 @@
           <a:p>
             <a:fld id="{7CD6D201-3712-4708-B8BD-34638CB62F40}" type="datetimeFigureOut">
               <a:rPr lang="en-US" smtClean="0"/>
-              <a:t>12/30/2025</a:t>
+              <a:t>1/20/2026</a:t>
             </a:fld>
             <a:endParaRPr lang="en-US"/>
           </a:p>
@@ -1110,7 +1113,7 @@
           <a:p>
             <a:fld id="{7CD6D201-3712-4708-B8BD-34638CB62F40}" type="datetimeFigureOut">
               <a:rPr lang="en-US" smtClean="0"/>
-              <a:t>12/30/2025</a:t>
+              <a:t>1/20/2026</a:t>
             </a:fld>
             <a:endParaRPr lang="en-US"/>
           </a:p>
@@ -1308,7 +1311,7 @@
           <a:p>
             <a:fld id="{7CD6D201-3712-4708-B8BD-34638CB62F40}" type="datetimeFigureOut">
               <a:rPr lang="en-US" smtClean="0"/>
-              <a:t>12/30/2025</a:t>
+              <a:t>1/20/2026</a:t>
             </a:fld>
             <a:endParaRPr lang="en-US"/>
           </a:p>
@@ -1583,7 +1586,7 @@
           <a:p>
             <a:fld id="{7CD6D201-3712-4708-B8BD-34638CB62F40}" type="datetimeFigureOut">
               <a:rPr lang="en-US" smtClean="0"/>
-              <a:t>12/30/2025</a:t>
+              <a:t>1/20/2026</a:t>
             </a:fld>
             <a:endParaRPr lang="en-US"/>
           </a:p>
@@ -1848,7 +1851,7 @@
           <a:p>
             <a:fld id="{7CD6D201-3712-4708-B8BD-34638CB62F40}" type="datetimeFigureOut">
               <a:rPr lang="en-US" smtClean="0"/>
-              <a:t>12/30/2025</a:t>
+              <a:t>1/20/2026</a:t>
             </a:fld>
             <a:endParaRPr lang="en-US"/>
           </a:p>
@@ -2260,7 +2263,7 @@
           <a:p>
             <a:fld id="{7CD6D201-3712-4708-B8BD-34638CB62F40}" type="datetimeFigureOut">
               <a:rPr lang="en-US" smtClean="0"/>
-              <a:t>12/30/2025</a:t>
+              <a:t>1/20/2026</a:t>
             </a:fld>
             <a:endParaRPr lang="en-US"/>
           </a:p>
@@ -2401,7 +2404,7 @@
           <a:p>
             <a:fld id="{7CD6D201-3712-4708-B8BD-34638CB62F40}" type="datetimeFigureOut">
               <a:rPr lang="en-US" smtClean="0"/>
-              <a:t>12/30/2025</a:t>
+              <a:t>1/20/2026</a:t>
             </a:fld>
             <a:endParaRPr lang="en-US"/>
           </a:p>
@@ -2514,7 +2517,7 @@
           <a:p>
             <a:fld id="{7CD6D201-3712-4708-B8BD-34638CB62F40}" type="datetimeFigureOut">
               <a:rPr lang="en-US" smtClean="0"/>
-              <a:t>12/30/2025</a:t>
+              <a:t>1/20/2026</a:t>
             </a:fld>
             <a:endParaRPr lang="en-US"/>
           </a:p>
@@ -2825,7 +2828,7 @@
           <a:p>
             <a:fld id="{7CD6D201-3712-4708-B8BD-34638CB62F40}" type="datetimeFigureOut">
               <a:rPr lang="en-US" smtClean="0"/>
-              <a:t>12/30/2025</a:t>
+              <a:t>1/20/2026</a:t>
             </a:fld>
             <a:endParaRPr lang="en-US"/>
           </a:p>
@@ -3113,7 +3116,7 @@
           <a:p>
             <a:fld id="{7CD6D201-3712-4708-B8BD-34638CB62F40}" type="datetimeFigureOut">
               <a:rPr lang="en-US" smtClean="0"/>
-              <a:t>12/30/2025</a:t>
+              <a:t>1/20/2026</a:t>
             </a:fld>
             <a:endParaRPr lang="en-US"/>
           </a:p>
@@ -3354,7 +3357,7 @@
           <a:p>
             <a:fld id="{7CD6D201-3712-4708-B8BD-34638CB62F40}" type="datetimeFigureOut">
               <a:rPr lang="en-US" smtClean="0"/>
-              <a:t>12/30/2025</a:t>
+              <a:t>1/20/2026</a:t>
             </a:fld>
             <a:endParaRPr lang="en-US"/>
           </a:p>
@@ -3885,6 +3888,429 @@
           <p:cNvPr id="2" name="Title 1">
             <a:extLst>
               <a:ext uri="{FF2B5EF4-FFF2-40B4-BE49-F238E27FC236}">
+                <a16:creationId xmlns:a16="http://schemas.microsoft.com/office/drawing/2014/main" id="{3020C385-061B-DFF4-22BA-1E99B25FEA0F}"/>
+              </a:ext>
+            </a:extLst>
+          </p:cNvPr>
+          <p:cNvSpPr>
+            <a:spLocks noGrp="1"/>
+          </p:cNvSpPr>
+          <p:nvPr>
+            <p:ph type="title"/>
+          </p:nvPr>
+        </p:nvSpPr>
+        <p:spPr/>
+        <p:txBody>
+          <a:bodyPr/>
+          <a:lstStyle/>
+          <a:p>
+            <a:r>
+              <a:rPr lang="en-US" dirty="0"/>
+              <a:t>Portfolio Service</a:t>
+            </a:r>
+          </a:p>
+        </p:txBody>
+      </p:sp>
+      <p:sp>
+        <p:nvSpPr>
+          <p:cNvPr id="3" name="Content Placeholder 2">
+            <a:extLst>
+              <a:ext uri="{FF2B5EF4-FFF2-40B4-BE49-F238E27FC236}">
+                <a16:creationId xmlns:a16="http://schemas.microsoft.com/office/drawing/2014/main" id="{1B86A073-9C9F-E90E-2B6F-1F5DF496956E}"/>
+              </a:ext>
+            </a:extLst>
+          </p:cNvPr>
+          <p:cNvSpPr>
+            <a:spLocks noGrp="1"/>
+          </p:cNvSpPr>
+          <p:nvPr>
+            <p:ph idx="1"/>
+          </p:nvPr>
+        </p:nvSpPr>
+        <p:spPr/>
+        <p:txBody>
+          <a:bodyPr>
+            <a:normAutofit/>
+          </a:bodyPr>
+          <a:lstStyle/>
+          <a:p>
+            <a:r>
+              <a:rPr lang="en-US" dirty="0"/>
+              <a:t>Responsibilities:</a:t>
+            </a:r>
+          </a:p>
+          <a:p>
+            <a:pPr lvl="1"/>
+            <a:r>
+              <a:rPr lang="en-US" dirty="0"/>
+              <a:t>Maintain current positions, cash, and </a:t>
+            </a:r>
+            <a:r>
+              <a:rPr lang="en-US" dirty="0" err="1"/>
+              <a:t>PnL</a:t>
+            </a:r>
+            <a:endParaRPr lang="en-US" dirty="0"/>
+          </a:p>
+          <a:p>
+            <a:pPr lvl="1"/>
+            <a:r>
+              <a:rPr lang="en-US" dirty="0"/>
+              <a:t>Track fills/trades (from execution service)</a:t>
+            </a:r>
+          </a:p>
+          <a:p>
+            <a:pPr lvl="1"/>
+            <a:r>
+              <a:rPr lang="en-US" dirty="0"/>
+              <a:t>Expose:</a:t>
+            </a:r>
+          </a:p>
+          <a:p>
+            <a:pPr lvl="2"/>
+            <a:r>
+              <a:rPr lang="en-US" dirty="0"/>
+              <a:t>GET /portfolio</a:t>
+            </a:r>
+          </a:p>
+          <a:p>
+            <a:pPr lvl="2"/>
+            <a:r>
+              <a:rPr lang="en-US" dirty="0"/>
+              <a:t>POST /rebalance (given target weights)</a:t>
+            </a:r>
+          </a:p>
+        </p:txBody>
+      </p:sp>
+    </p:spTree>
+    <p:extLst>
+      <p:ext uri="{BB962C8B-B14F-4D97-AF65-F5344CB8AC3E}">
+        <p14:creationId xmlns:p14="http://schemas.microsoft.com/office/powerpoint/2010/main" val="377062414"/>
+      </p:ext>
+    </p:extLst>
+  </p:cSld>
+  <p:clrMapOvr>
+    <a:masterClrMapping/>
+  </p:clrMapOvr>
+</p:sld>
+</file>
+
+<file path=ppt/slides/slide11.xml><?xml version="1.0" encoding="utf-8"?>
+<p:sld xmlns:a="http://schemas.openxmlformats.org/drawingml/2006/main" xmlns:r="http://schemas.openxmlformats.org/officeDocument/2006/relationships" xmlns:p="http://schemas.openxmlformats.org/presentationml/2006/main">
+  <p:cSld>
+    <p:spTree>
+      <p:nvGrpSpPr>
+        <p:cNvPr id="1" name=""/>
+        <p:cNvGrpSpPr/>
+        <p:nvPr/>
+      </p:nvGrpSpPr>
+      <p:grpSpPr>
+        <a:xfrm>
+          <a:off x="0" y="0"/>
+          <a:ext cx="0" cy="0"/>
+          <a:chOff x="0" y="0"/>
+          <a:chExt cx="0" cy="0"/>
+        </a:xfrm>
+      </p:grpSpPr>
+      <p:sp>
+        <p:nvSpPr>
+          <p:cNvPr id="2" name="Title 1">
+            <a:extLst>
+              <a:ext uri="{FF2B5EF4-FFF2-40B4-BE49-F238E27FC236}">
+                <a16:creationId xmlns:a16="http://schemas.microsoft.com/office/drawing/2014/main" id="{CC21E9AB-CEFC-8065-3552-3C2A0F23920F}"/>
+              </a:ext>
+            </a:extLst>
+          </p:cNvPr>
+          <p:cNvSpPr>
+            <a:spLocks noGrp="1"/>
+          </p:cNvSpPr>
+          <p:nvPr>
+            <p:ph type="title"/>
+          </p:nvPr>
+        </p:nvSpPr>
+        <p:spPr/>
+        <p:txBody>
+          <a:bodyPr/>
+          <a:lstStyle/>
+          <a:p>
+            <a:r>
+              <a:rPr lang="en-US" dirty="0"/>
+              <a:t>Risk Service – Not yet implemented</a:t>
+            </a:r>
+          </a:p>
+        </p:txBody>
+      </p:sp>
+      <p:sp>
+        <p:nvSpPr>
+          <p:cNvPr id="3" name="Content Placeholder 2">
+            <a:extLst>
+              <a:ext uri="{FF2B5EF4-FFF2-40B4-BE49-F238E27FC236}">
+                <a16:creationId xmlns:a16="http://schemas.microsoft.com/office/drawing/2014/main" id="{F77B2BBE-26E9-1355-EF06-D132B5A746E1}"/>
+              </a:ext>
+            </a:extLst>
+          </p:cNvPr>
+          <p:cNvSpPr>
+            <a:spLocks noGrp="1"/>
+          </p:cNvSpPr>
+          <p:nvPr>
+            <p:ph idx="1"/>
+          </p:nvPr>
+        </p:nvSpPr>
+        <p:spPr/>
+        <p:txBody>
+          <a:bodyPr>
+            <a:normAutofit/>
+          </a:bodyPr>
+          <a:lstStyle/>
+          <a:p>
+            <a:r>
+              <a:rPr lang="en-US" dirty="0"/>
+              <a:t>Responsibilities:</a:t>
+            </a:r>
+          </a:p>
+          <a:p>
+            <a:pPr lvl="1"/>
+            <a:r>
+              <a:rPr lang="en-US" dirty="0"/>
+              <a:t>Compute:</a:t>
+            </a:r>
+          </a:p>
+          <a:p>
+            <a:pPr lvl="1"/>
+            <a:r>
+              <a:rPr lang="en-US" dirty="0"/>
+              <a:t>Volatility, drawdown, exposure by asset/sector, leverage, etc.</a:t>
+            </a:r>
+          </a:p>
+          <a:p>
+            <a:pPr lvl="1"/>
+            <a:r>
+              <a:rPr lang="en-US" dirty="0"/>
+              <a:t>Enforce constraints:</a:t>
+            </a:r>
+          </a:p>
+          <a:p>
+            <a:pPr lvl="1"/>
+            <a:r>
+              <a:rPr lang="en-US" dirty="0"/>
+              <a:t>Block/reduce orders that violate risk rules</a:t>
+            </a:r>
+          </a:p>
+          <a:p>
+            <a:pPr lvl="1"/>
+            <a:r>
+              <a:rPr lang="en-US" dirty="0"/>
+              <a:t>Expose:</a:t>
+            </a:r>
+          </a:p>
+          <a:p>
+            <a:pPr lvl="2"/>
+            <a:r>
+              <a:rPr lang="en-US" dirty="0"/>
+              <a:t>POST /check-orders (returns approved/trimmed orders + warnings)</a:t>
+            </a:r>
+          </a:p>
+          <a:p>
+            <a:pPr lvl="2"/>
+            <a:r>
+              <a:rPr lang="en-US" dirty="0"/>
+              <a:t>GET /risk-metrics</a:t>
+            </a:r>
+          </a:p>
+        </p:txBody>
+      </p:sp>
+    </p:spTree>
+    <p:extLst>
+      <p:ext uri="{BB962C8B-B14F-4D97-AF65-F5344CB8AC3E}">
+        <p14:creationId xmlns:p14="http://schemas.microsoft.com/office/powerpoint/2010/main" val="4231797650"/>
+      </p:ext>
+    </p:extLst>
+  </p:cSld>
+  <p:clrMapOvr>
+    <a:masterClrMapping/>
+  </p:clrMapOvr>
+</p:sld>
+</file>
+
+<file path=ppt/slides/slide12.xml><?xml version="1.0" encoding="utf-8"?>
+<p:sld xmlns:a="http://schemas.openxmlformats.org/drawingml/2006/main" xmlns:r="http://schemas.openxmlformats.org/officeDocument/2006/relationships" xmlns:p="http://schemas.openxmlformats.org/presentationml/2006/main">
+  <p:cSld>
+    <p:spTree>
+      <p:nvGrpSpPr>
+        <p:cNvPr id="1" name=""/>
+        <p:cNvGrpSpPr/>
+        <p:nvPr/>
+      </p:nvGrpSpPr>
+      <p:grpSpPr>
+        <a:xfrm>
+          <a:off x="0" y="0"/>
+          <a:ext cx="0" cy="0"/>
+          <a:chOff x="0" y="0"/>
+          <a:chExt cx="0" cy="0"/>
+        </a:xfrm>
+      </p:grpSpPr>
+      <p:sp>
+        <p:nvSpPr>
+          <p:cNvPr id="2" name="Title 1">
+            <a:extLst>
+              <a:ext uri="{FF2B5EF4-FFF2-40B4-BE49-F238E27FC236}">
+                <a16:creationId xmlns:a16="http://schemas.microsoft.com/office/drawing/2014/main" id="{EF991D1D-6992-B032-23B2-41A7A13C4C4F}"/>
+              </a:ext>
+            </a:extLst>
+          </p:cNvPr>
+          <p:cNvSpPr>
+            <a:spLocks noGrp="1"/>
+          </p:cNvSpPr>
+          <p:nvPr>
+            <p:ph type="title"/>
+          </p:nvPr>
+        </p:nvSpPr>
+        <p:spPr/>
+        <p:txBody>
+          <a:bodyPr/>
+          <a:lstStyle/>
+          <a:p>
+            <a:r>
+              <a:rPr lang="en-US" dirty="0"/>
+              <a:t>Execution Service</a:t>
+            </a:r>
+          </a:p>
+        </p:txBody>
+      </p:sp>
+      <p:sp>
+        <p:nvSpPr>
+          <p:cNvPr id="3" name="Content Placeholder 2">
+            <a:extLst>
+              <a:ext uri="{FF2B5EF4-FFF2-40B4-BE49-F238E27FC236}">
+                <a16:creationId xmlns:a16="http://schemas.microsoft.com/office/drawing/2014/main" id="{D855AE09-8A09-72AC-4D28-6B264E61F5AA}"/>
+              </a:ext>
+            </a:extLst>
+          </p:cNvPr>
+          <p:cNvSpPr>
+            <a:spLocks noGrp="1"/>
+          </p:cNvSpPr>
+          <p:nvPr>
+            <p:ph idx="1"/>
+          </p:nvPr>
+        </p:nvSpPr>
+        <p:spPr/>
+        <p:txBody>
+          <a:bodyPr>
+            <a:normAutofit fontScale="92500"/>
+          </a:bodyPr>
+          <a:lstStyle/>
+          <a:p>
+            <a:r>
+              <a:rPr lang="en-US" dirty="0"/>
+              <a:t>Responsibilities:</a:t>
+            </a:r>
+          </a:p>
+          <a:p>
+            <a:pPr lvl="1"/>
+            <a:r>
+              <a:rPr lang="en-US" dirty="0"/>
+              <a:t>Take orders from portfolio service (after risk check)</a:t>
+            </a:r>
+          </a:p>
+          <a:p>
+            <a:pPr lvl="1"/>
+            <a:r>
+              <a:rPr lang="en-US" dirty="0"/>
+              <a:t>In v1: simulate fills using last/close price</a:t>
+            </a:r>
+          </a:p>
+          <a:p>
+            <a:pPr lvl="1"/>
+            <a:r>
+              <a:rPr lang="en-US" dirty="0"/>
+              <a:t>Optionally: integrate a paper trading API later (Alpaca, Interactive Brokers, etc.)</a:t>
+            </a:r>
+          </a:p>
+          <a:p>
+            <a:pPr lvl="1"/>
+            <a:r>
+              <a:rPr lang="en-US" dirty="0"/>
+              <a:t>Maintain trade history table</a:t>
+            </a:r>
+          </a:p>
+          <a:p>
+            <a:pPr lvl="1"/>
+            <a:r>
+              <a:rPr lang="en-US" dirty="0"/>
+              <a:t>Monitor synchronicity with portfolio service. </a:t>
+            </a:r>
+          </a:p>
+          <a:p>
+            <a:pPr lvl="2"/>
+            <a:r>
+              <a:rPr lang="en-US" dirty="0"/>
+              <a:t>If Execution service cannot properly update portfolio service, trade execution for buy orders is blocked until the portfolio is rebuilt using the execution service’s trade history</a:t>
+            </a:r>
+          </a:p>
+          <a:p>
+            <a:pPr lvl="2"/>
+            <a:r>
+              <a:rPr lang="en-US" dirty="0"/>
+              <a:t>Prevents further decoupling and undesired signal generation / portfolio rebalancing</a:t>
+            </a:r>
+          </a:p>
+          <a:p>
+            <a:pPr lvl="1"/>
+            <a:r>
+              <a:rPr lang="en-US" dirty="0"/>
+              <a:t>Expose:</a:t>
+            </a:r>
+          </a:p>
+          <a:p>
+            <a:pPr lvl="2"/>
+            <a:r>
+              <a:rPr lang="en-US" dirty="0"/>
+              <a:t>POST /execute-orders</a:t>
+            </a:r>
+          </a:p>
+          <a:p>
+            <a:pPr lvl="2"/>
+            <a:r>
+              <a:rPr lang="en-US" dirty="0"/>
+              <a:t>GET /orders, GET /trades</a:t>
+            </a:r>
+          </a:p>
+        </p:txBody>
+      </p:sp>
+    </p:spTree>
+    <p:extLst>
+      <p:ext uri="{BB962C8B-B14F-4D97-AF65-F5344CB8AC3E}">
+        <p14:creationId xmlns:p14="http://schemas.microsoft.com/office/powerpoint/2010/main" val="1836074655"/>
+      </p:ext>
+    </p:extLst>
+  </p:cSld>
+  <p:clrMapOvr>
+    <a:masterClrMapping/>
+  </p:clrMapOvr>
+</p:sld>
+</file>
+
+<file path=ppt/slides/slide13.xml><?xml version="1.0" encoding="utf-8"?>
+<p:sld xmlns:a="http://schemas.openxmlformats.org/drawingml/2006/main" xmlns:r="http://schemas.openxmlformats.org/officeDocument/2006/relationships" xmlns:p="http://schemas.openxmlformats.org/presentationml/2006/main">
+  <p:cSld>
+    <p:spTree>
+      <p:nvGrpSpPr>
+        <p:cNvPr id="1" name=""/>
+        <p:cNvGrpSpPr/>
+        <p:nvPr/>
+      </p:nvGrpSpPr>
+      <p:grpSpPr>
+        <a:xfrm>
+          <a:off x="0" y="0"/>
+          <a:ext cx="0" cy="0"/>
+          <a:chOff x="0" y="0"/>
+          <a:chExt cx="0" cy="0"/>
+        </a:xfrm>
+      </p:grpSpPr>
+      <p:sp>
+        <p:nvSpPr>
+          <p:cNvPr id="2" name="Title 1">
+            <a:extLst>
+              <a:ext uri="{FF2B5EF4-FFF2-40B4-BE49-F238E27FC236}">
                 <a16:creationId xmlns:a16="http://schemas.microsoft.com/office/drawing/2014/main" id="{AB55B081-EDEE-EC7D-4F43-7287AF508D6E}"/>
               </a:ext>
             </a:extLst>
@@ -3903,7 +4329,7 @@
           <a:p>
             <a:r>
               <a:rPr lang="en-US" dirty="0"/>
-              <a:t>Dashboard</a:t>
+              <a:t>Dashboard – Not yet Implemented</a:t>
             </a:r>
           </a:p>
         </p:txBody>
@@ -4377,10 +4803,7 @@
               <a:rPr lang="en-US" sz="1900" dirty="0" err="1"/>
               <a:t>Kuberbetes</a:t>
             </a:r>
-            <a:r>
-              <a:rPr lang="en-US" sz="1900" dirty="0"/>
-              <a:t> + AWS</a:t>
-            </a:r>
+            <a:endParaRPr lang="en-US" sz="1900" dirty="0"/>
           </a:p>
           <a:p>
             <a:r>
@@ -4424,168 +4847,6 @@
 </file>
 
 <file path=ppt/slides/slide3.xml><?xml version="1.0" encoding="utf-8"?>
-<p:sld xmlns:a="http://schemas.openxmlformats.org/drawingml/2006/main" xmlns:r="http://schemas.openxmlformats.org/officeDocument/2006/relationships" xmlns:p="http://schemas.openxmlformats.org/presentationml/2006/main">
-  <p:cSld>
-    <p:spTree>
-      <p:nvGrpSpPr>
-        <p:cNvPr id="1" name=""/>
-        <p:cNvGrpSpPr/>
-        <p:nvPr/>
-      </p:nvGrpSpPr>
-      <p:grpSpPr>
-        <a:xfrm>
-          <a:off x="0" y="0"/>
-          <a:ext cx="0" cy="0"/>
-          <a:chOff x="0" y="0"/>
-          <a:chExt cx="0" cy="0"/>
-        </a:xfrm>
-      </p:grpSpPr>
-      <p:sp>
-        <p:nvSpPr>
-          <p:cNvPr id="2" name="Title 1">
-            <a:extLst>
-              <a:ext uri="{FF2B5EF4-FFF2-40B4-BE49-F238E27FC236}">
-                <a16:creationId xmlns:a16="http://schemas.microsoft.com/office/drawing/2014/main" id="{54EF426B-171D-6065-125F-45E2C780E2BC}"/>
-              </a:ext>
-            </a:extLst>
-          </p:cNvPr>
-          <p:cNvSpPr>
-            <a:spLocks noGrp="1"/>
-          </p:cNvSpPr>
-          <p:nvPr>
-            <p:ph type="title"/>
-          </p:nvPr>
-        </p:nvSpPr>
-        <p:spPr/>
-        <p:txBody>
-          <a:bodyPr/>
-          <a:lstStyle/>
-          <a:p>
-            <a:r>
-              <a:rPr lang="en-US" dirty="0"/>
-              <a:t>High Level Architecture</a:t>
-            </a:r>
-          </a:p>
-        </p:txBody>
-      </p:sp>
-      <p:sp>
-        <p:nvSpPr>
-          <p:cNvPr id="3" name="Content Placeholder 2">
-            <a:extLst>
-              <a:ext uri="{FF2B5EF4-FFF2-40B4-BE49-F238E27FC236}">
-                <a16:creationId xmlns:a16="http://schemas.microsoft.com/office/drawing/2014/main" id="{C4418F4C-470F-D520-0148-C104067E2DA7}"/>
-              </a:ext>
-            </a:extLst>
-          </p:cNvPr>
-          <p:cNvSpPr>
-            <a:spLocks noGrp="1"/>
-          </p:cNvSpPr>
-          <p:nvPr>
-            <p:ph idx="1"/>
-          </p:nvPr>
-        </p:nvSpPr>
-        <p:spPr/>
-        <p:txBody>
-          <a:bodyPr/>
-          <a:lstStyle/>
-          <a:p>
-            <a:r>
-              <a:rPr lang="en-US" b="1" dirty="0"/>
-              <a:t>Data Service – </a:t>
-            </a:r>
-            <a:r>
-              <a:rPr lang="en-US" dirty="0"/>
-              <a:t>gets cleans and serves market data</a:t>
-            </a:r>
-          </a:p>
-          <a:p>
-            <a:r>
-              <a:rPr lang="en-US" b="1" dirty="0"/>
-              <a:t>Strategy Service – </a:t>
-            </a:r>
-            <a:r>
-              <a:rPr lang="en-US" dirty="0"/>
-              <a:t>turns data into signals</a:t>
-            </a:r>
-          </a:p>
-          <a:p>
-            <a:r>
-              <a:rPr lang="en-US" b="1" dirty="0"/>
-              <a:t>Portfolio Service – </a:t>
-            </a:r>
-            <a:r>
-              <a:rPr lang="en-US" dirty="0"/>
-              <a:t>tracks positions, </a:t>
-            </a:r>
-            <a:r>
-              <a:rPr lang="en-US" dirty="0" err="1"/>
-              <a:t>PnL</a:t>
-            </a:r>
-            <a:r>
-              <a:rPr lang="en-US" dirty="0"/>
-              <a:t>, and orders</a:t>
-            </a:r>
-          </a:p>
-          <a:p>
-            <a:r>
-              <a:rPr lang="en-US" b="1" dirty="0"/>
-              <a:t>Risk Service </a:t>
-            </a:r>
-            <a:r>
-              <a:rPr lang="en-US" dirty="0"/>
-              <a:t>– monitors risk and enforces limits</a:t>
-            </a:r>
-          </a:p>
-          <a:p>
-            <a:r>
-              <a:rPr lang="en-US" b="1" dirty="0"/>
-              <a:t>Execution Service</a:t>
-            </a:r>
-            <a:r>
-              <a:rPr lang="en-US" dirty="0"/>
-              <a:t> – turns orders into trades (simulated or live)</a:t>
-            </a:r>
-          </a:p>
-          <a:p>
-            <a:r>
-              <a:rPr lang="en-US" b="1" dirty="0"/>
-              <a:t>Dashboard – </a:t>
-            </a:r>
-            <a:r>
-              <a:rPr lang="en-US" dirty="0"/>
-              <a:t>visualizes everything for humans</a:t>
-            </a:r>
-          </a:p>
-          <a:p>
-            <a:r>
-              <a:rPr lang="en-US" b="1" i="1" dirty="0"/>
-              <a:t>Correlation service –</a:t>
-            </a:r>
-            <a:r>
-              <a:rPr lang="en-US" i="1" dirty="0"/>
-              <a:t> Manages how correlated positions in portfolio are – likely part of strategy</a:t>
-            </a:r>
-            <a:endParaRPr lang="en-US" b="1" i="1" dirty="0"/>
-          </a:p>
-          <a:p>
-            <a:endParaRPr lang="en-US" b="1" dirty="0"/>
-          </a:p>
-        </p:txBody>
-      </p:sp>
-    </p:spTree>
-    <p:extLst>
-      <p:ext uri="{BB962C8B-B14F-4D97-AF65-F5344CB8AC3E}">
-        <p14:creationId xmlns:p14="http://schemas.microsoft.com/office/powerpoint/2010/main" val="3535126061"/>
-      </p:ext>
-    </p:extLst>
-  </p:cSld>
-  <p:clrMapOvr>
-    <a:masterClrMapping/>
-  </p:clrMapOvr>
-</p:sld>
-</file>
-
-<file path=ppt/slides/slide4.xml><?xml version="1.0" encoding="utf-8"?>
 <p:sld xmlns:a="http://schemas.openxmlformats.org/drawingml/2006/main" xmlns:r="http://schemas.openxmlformats.org/officeDocument/2006/relationships" xmlns:p="http://schemas.openxmlformats.org/presentationml/2006/main">
   <p:cSld>
     <p:spTree>
@@ -6441,6 +6702,193 @@
 </p:sld>
 </file>
 
+<file path=ppt/slides/slide4.xml><?xml version="1.0" encoding="utf-8"?>
+<p:sld xmlns:a="http://schemas.openxmlformats.org/drawingml/2006/main" xmlns:r="http://schemas.openxmlformats.org/officeDocument/2006/relationships" xmlns:p="http://schemas.openxmlformats.org/presentationml/2006/main">
+  <p:cSld>
+    <p:spTree>
+      <p:nvGrpSpPr>
+        <p:cNvPr id="1" name=""/>
+        <p:cNvGrpSpPr/>
+        <p:nvPr/>
+      </p:nvGrpSpPr>
+      <p:grpSpPr>
+        <a:xfrm>
+          <a:off x="0" y="0"/>
+          <a:ext cx="0" cy="0"/>
+          <a:chOff x="0" y="0"/>
+          <a:chExt cx="0" cy="0"/>
+        </a:xfrm>
+      </p:grpSpPr>
+      <p:sp>
+        <p:nvSpPr>
+          <p:cNvPr id="2" name="Title 1">
+            <a:extLst>
+              <a:ext uri="{FF2B5EF4-FFF2-40B4-BE49-F238E27FC236}">
+                <a16:creationId xmlns:a16="http://schemas.microsoft.com/office/drawing/2014/main" id="{54EF426B-171D-6065-125F-45E2C780E2BC}"/>
+              </a:ext>
+            </a:extLst>
+          </p:cNvPr>
+          <p:cNvSpPr>
+            <a:spLocks noGrp="1"/>
+          </p:cNvSpPr>
+          <p:nvPr>
+            <p:ph type="title"/>
+          </p:nvPr>
+        </p:nvSpPr>
+        <p:spPr/>
+        <p:txBody>
+          <a:bodyPr/>
+          <a:lstStyle/>
+          <a:p>
+            <a:r>
+              <a:rPr lang="en-US" dirty="0"/>
+              <a:t>High Level Architecture</a:t>
+            </a:r>
+          </a:p>
+        </p:txBody>
+      </p:sp>
+      <p:sp>
+        <p:nvSpPr>
+          <p:cNvPr id="3" name="Content Placeholder 2">
+            <a:extLst>
+              <a:ext uri="{FF2B5EF4-FFF2-40B4-BE49-F238E27FC236}">
+                <a16:creationId xmlns:a16="http://schemas.microsoft.com/office/drawing/2014/main" id="{C4418F4C-470F-D520-0148-C104067E2DA7}"/>
+              </a:ext>
+            </a:extLst>
+          </p:cNvPr>
+          <p:cNvSpPr>
+            <a:spLocks noGrp="1"/>
+          </p:cNvSpPr>
+          <p:nvPr>
+            <p:ph idx="1"/>
+          </p:nvPr>
+        </p:nvSpPr>
+        <p:spPr/>
+        <p:txBody>
+          <a:bodyPr>
+            <a:normAutofit fontScale="70000" lnSpcReduction="20000"/>
+          </a:bodyPr>
+          <a:lstStyle/>
+          <a:p>
+            <a:r>
+              <a:rPr lang="en-US" b="1" dirty="0"/>
+              <a:t>Data Service – </a:t>
+            </a:r>
+            <a:r>
+              <a:rPr lang="en-US" dirty="0"/>
+              <a:t>gets cleans stores and serves daily OHLCV market data, maintains symbol universe, single source of data for other services</a:t>
+            </a:r>
+          </a:p>
+          <a:p>
+            <a:r>
+              <a:rPr lang="en-US" b="1" dirty="0" err="1"/>
+              <a:t>MarketData</a:t>
+            </a:r>
+            <a:r>
+              <a:rPr lang="en-US" b="1" dirty="0"/>
+              <a:t> Service – </a:t>
+            </a:r>
+            <a:r>
+              <a:rPr lang="en-US" dirty="0"/>
+              <a:t>Streams (no storing) intraday market data for symbols in Data Service’s Intraday Watchlist</a:t>
+            </a:r>
+          </a:p>
+          <a:p>
+            <a:r>
+              <a:rPr lang="en-US" b="1" dirty="0"/>
+              <a:t>Strategy Service – </a:t>
+            </a:r>
+            <a:r>
+              <a:rPr lang="en-US" dirty="0"/>
+              <a:t>turns data into signals (BUY/SELL), identifies symbols to add to Data Service’s symbol universe for daily Market data or the Intraday watchlist for intraday price action -&gt; used for evaluating when sell orders are hit since not executing through broker</a:t>
+            </a:r>
+          </a:p>
+          <a:p>
+            <a:r>
+              <a:rPr lang="en-US" b="1" dirty="0"/>
+              <a:t>Portfolio Service – </a:t>
+            </a:r>
+            <a:r>
+              <a:rPr lang="en-US" dirty="0"/>
+              <a:t>tracks positions, </a:t>
+            </a:r>
+            <a:r>
+              <a:rPr lang="en-US" dirty="0" err="1"/>
+              <a:t>PnL</a:t>
+            </a:r>
+            <a:r>
+              <a:rPr lang="en-US" dirty="0"/>
+              <a:t>, and orders</a:t>
+            </a:r>
+          </a:p>
+          <a:p>
+            <a:r>
+              <a:rPr lang="en-US" b="1" dirty="0"/>
+              <a:t>Risk Service </a:t>
+            </a:r>
+            <a:r>
+              <a:rPr lang="en-US" dirty="0"/>
+              <a:t>– monitors risk and enforces limits – </a:t>
+            </a:r>
+            <a:r>
+              <a:rPr lang="en-US" i="1" dirty="0"/>
+              <a:t>coming soon</a:t>
+            </a:r>
+          </a:p>
+          <a:p>
+            <a:r>
+              <a:rPr lang="en-US" b="1" dirty="0"/>
+              <a:t>Execution Service</a:t>
+            </a:r>
+            <a:r>
+              <a:rPr lang="en-US" dirty="0"/>
+              <a:t> – turns orders into trades (simulated or live), executes trades and maintains trade history, currently pull live price data at time order received as simulated execution</a:t>
+            </a:r>
+          </a:p>
+          <a:p>
+            <a:r>
+              <a:rPr lang="en-US" b="1" dirty="0"/>
+              <a:t>Dashboard – </a:t>
+            </a:r>
+            <a:r>
+              <a:rPr lang="en-US" dirty="0"/>
+              <a:t>visualizes portfolio and strategy performance –</a:t>
+            </a:r>
+            <a:r>
+              <a:rPr lang="en-US" i="1" dirty="0"/>
+              <a:t>coming soon</a:t>
+            </a:r>
+            <a:endParaRPr lang="en-US" dirty="0"/>
+          </a:p>
+          <a:p>
+            <a:r>
+              <a:rPr lang="en-US" b="1" i="1" strike="sngStrike" dirty="0"/>
+              <a:t>Correlation service –</a:t>
+            </a:r>
+            <a:r>
+              <a:rPr lang="en-US" i="1" strike="sngStrike" dirty="0"/>
+              <a:t> Manages how correlated positions in portfolio are – likely part of strategy</a:t>
+            </a:r>
+            <a:endParaRPr lang="en-US" b="1" i="1" strike="sngStrike" dirty="0"/>
+          </a:p>
+          <a:p>
+            <a:endParaRPr lang="en-US" b="1" dirty="0"/>
+          </a:p>
+        </p:txBody>
+      </p:sp>
+    </p:spTree>
+    <p:extLst>
+      <p:ext uri="{BB962C8B-B14F-4D97-AF65-F5344CB8AC3E}">
+        <p14:creationId xmlns:p14="http://schemas.microsoft.com/office/powerpoint/2010/main" val="3535126061"/>
+      </p:ext>
+    </p:extLst>
+  </p:cSld>
+  <p:clrMapOvr>
+    <a:masterClrMapping/>
+  </p:clrMapOvr>
+</p:sld>
+</file>
+
 <file path=ppt/slides/slide5.xml><?xml version="1.0" encoding="utf-8"?>
 <p:sld xmlns:a="http://schemas.openxmlformats.org/drawingml/2006/main" xmlns:r="http://schemas.openxmlformats.org/officeDocument/2006/relationships" xmlns:p="http://schemas.openxmlformats.org/presentationml/2006/main">
   <p:cSld>
@@ -6463,7 +6911,7 @@
           <p:cNvPr id="2" name="Title 1">
             <a:extLst>
               <a:ext uri="{FF2B5EF4-FFF2-40B4-BE49-F238E27FC236}">
-                <a16:creationId xmlns:a16="http://schemas.microsoft.com/office/drawing/2014/main" id="{95F66B3A-B224-01CD-EAAC-C99D90E8B1D9}"/>
+                <a16:creationId xmlns:a16="http://schemas.microsoft.com/office/drawing/2014/main" id="{F09E3D8D-B3DE-AF52-9D6F-1B45AF0A27C5}"/>
               </a:ext>
             </a:extLst>
           </p:cNvPr>
@@ -6481,7 +6929,7 @@
           <a:p>
             <a:r>
               <a:rPr lang="en-US" dirty="0"/>
-              <a:t>Data Service</a:t>
+              <a:t>Running</a:t>
             </a:r>
           </a:p>
         </p:txBody>
@@ -6491,7 +6939,7 @@
           <p:cNvPr id="3" name="Content Placeholder 2">
             <a:extLst>
               <a:ext uri="{FF2B5EF4-FFF2-40B4-BE49-F238E27FC236}">
-                <a16:creationId xmlns:a16="http://schemas.microsoft.com/office/drawing/2014/main" id="{D62343FD-2382-76DD-86D6-19574C03C14C}"/>
+                <a16:creationId xmlns:a16="http://schemas.microsoft.com/office/drawing/2014/main" id="{BF1FE2A1-A3A5-7146-6405-F2A099FBA181}"/>
               </a:ext>
             </a:extLst>
           </p:cNvPr>
@@ -6504,88 +6952,125 @@
         </p:nvSpPr>
         <p:spPr/>
         <p:txBody>
-          <a:bodyPr/>
-          <a:lstStyle/>
-          <a:p>
-            <a:r>
-              <a:rPr lang="en-US" dirty="0"/>
-              <a:t>Responsibilities:</a:t>
-            </a:r>
-          </a:p>
-          <a:p>
-            <a:pPr lvl="1"/>
-            <a:r>
-              <a:rPr lang="en-US" dirty="0"/>
-              <a:t>Fetch OHLCV data from a provider (e.g., Alpha Vantage, Yahoo, etc.)</a:t>
-            </a:r>
-          </a:p>
-          <a:p>
-            <a:pPr lvl="1"/>
-            <a:r>
-              <a:rPr lang="en-US" dirty="0"/>
-              <a:t>Normalize and store it in your DB</a:t>
-            </a:r>
-          </a:p>
-          <a:p>
-            <a:pPr lvl="1"/>
-            <a:r>
-              <a:rPr lang="en-US" dirty="0"/>
-              <a:t>Expose endpoints like:</a:t>
-            </a:r>
-          </a:p>
-          <a:p>
-            <a:pPr lvl="2"/>
-            <a:r>
-              <a:rPr lang="en-US" dirty="0"/>
-              <a:t>GET /</a:t>
+          <a:bodyPr>
+            <a:normAutofit fontScale="55000" lnSpcReduction="20000"/>
+          </a:bodyPr>
+          <a:lstStyle/>
+          <a:p>
+            <a:r>
+              <a:rPr lang="en-US" dirty="0"/>
+              <a:t>To Run the services:</a:t>
+            </a:r>
+          </a:p>
+          <a:p>
+            <a:r>
+              <a:rPr lang="en-US" dirty="0"/>
+              <a:t>run .\run_all.bat</a:t>
+            </a:r>
+          </a:p>
+          <a:p>
+            <a:endParaRPr lang="en-US" dirty="0"/>
+          </a:p>
+          <a:p>
+            <a:r>
+              <a:rPr lang="en-US" dirty="0"/>
+              <a:t>This will open four command prompts and spin up the Data Service, Portfolio Service, Execution Service and the </a:t>
             </a:r>
             <a:r>
               <a:rPr lang="en-US" dirty="0" err="1"/>
-              <a:t>prices?symbol</a:t>
-            </a:r>
-            <a:r>
-              <a:rPr lang="en-US" dirty="0"/>
-              <a:t>=</a:t>
+              <a:t>MarketData</a:t>
+            </a:r>
+            <a:r>
+              <a:rPr lang="en-US" dirty="0"/>
+              <a:t> Service.</a:t>
+            </a:r>
+          </a:p>
+          <a:p>
+            <a:endParaRPr lang="en-US" dirty="0"/>
+          </a:p>
+          <a:p>
+            <a:r>
+              <a:rPr lang="en-US" dirty="0"/>
+              <a:t>To examine and </a:t>
             </a:r>
             <a:r>
               <a:rPr lang="en-US" dirty="0" err="1"/>
-              <a:t>SPY&amp;start</a:t>
-            </a:r>
-            <a:r>
-              <a:rPr lang="en-US" dirty="0"/>
-              <a:t>=...&amp;end=...</a:t>
-            </a:r>
-          </a:p>
-          <a:p>
-            <a:pPr lvl="2"/>
-            <a:r>
-              <a:rPr lang="en-US" dirty="0"/>
-              <a:t>POST /</a:t>
+              <a:t>playaround</a:t>
+            </a:r>
+            <a:r>
+              <a:rPr lang="en-US" dirty="0"/>
+              <a:t> with the REST endpoints for each service go to:</a:t>
+            </a:r>
+          </a:p>
+          <a:p>
+            <a:r>
+              <a:rPr lang="en-US" dirty="0"/>
+              <a:t>http://localhost:8001/docs =&gt; Data Service</a:t>
+            </a:r>
+          </a:p>
+          <a:p>
+            <a:r>
+              <a:rPr lang="en-US" dirty="0"/>
+              <a:t>http://localhost:8002/docs =&gt; Portfolio Service</a:t>
+            </a:r>
+          </a:p>
+          <a:p>
+            <a:r>
+              <a:rPr lang="en-US" dirty="0"/>
+              <a:t>http://localhost:8003/docs =&gt; Execution Service</a:t>
+            </a:r>
+          </a:p>
+          <a:p>
+            <a:r>
+              <a:rPr lang="en-US" dirty="0"/>
+              <a:t>http://localhost:8004/docs =&gt; </a:t>
             </a:r>
             <a:r>
               <a:rPr lang="en-US" dirty="0" err="1"/>
-              <a:t>refresh?symbol</a:t>
-            </a:r>
-            <a:r>
-              <a:rPr lang="en-US" dirty="0"/>
-              <a:t>=SPY (update recent data)</a:t>
-            </a:r>
-          </a:p>
-          <a:p>
-            <a:r>
-              <a:rPr lang="en-US" dirty="0"/>
-              <a:t>Why it matters: Everything downstream depends on clean, consistent data.</a:t>
+              <a:t>MarketData</a:t>
+            </a:r>
+            <a:r>
+              <a:rPr lang="en-US" dirty="0"/>
+              <a:t> Service</a:t>
+            </a:r>
+          </a:p>
+          <a:p>
+            <a:r>
+              <a:rPr lang="en-US" dirty="0"/>
+              <a:t>http://localhost:8010/docs =&gt; </a:t>
+            </a:r>
+            <a:r>
+              <a:rPr lang="en-US" dirty="0" err="1"/>
+              <a:t>IPO_Strategy</a:t>
+            </a:r>
+            <a:r>
+              <a:rPr lang="en-US" dirty="0"/>
+              <a:t> Service</a:t>
             </a:r>
           </a:p>
           <a:p>
             <a:endParaRPr lang="en-US" dirty="0"/>
+          </a:p>
+          <a:p>
+            <a:r>
+              <a:rPr lang="en-US" dirty="0"/>
+              <a:t>These services are built using </a:t>
+            </a:r>
+            <a:r>
+              <a:rPr lang="en-US" dirty="0" err="1"/>
+              <a:t>FastAPI</a:t>
+            </a:r>
+            <a:r>
+              <a:rPr lang="en-US" dirty="0"/>
+              <a:t>, at /docs you are able to try out the endpoints for yourself, read any documentation and examine the schemas associated with these routers. To try out an endpoint, click the drop down arrow on the desired route handler and click "try it out" in the top right hand corner. It will provide details on the input schema and output schema.</a:t>
+            </a:r>
           </a:p>
         </p:txBody>
       </p:sp>
     </p:spTree>
     <p:extLst>
       <p:ext uri="{BB962C8B-B14F-4D97-AF65-F5344CB8AC3E}">
-        <p14:creationId xmlns:p14="http://schemas.microsoft.com/office/powerpoint/2010/main" val="252910237"/>
+        <p14:creationId xmlns:p14="http://schemas.microsoft.com/office/powerpoint/2010/main" val="3162343276"/>
       </p:ext>
     </p:extLst>
   </p:cSld>
@@ -6617,7 +7102,7 @@
           <p:cNvPr id="2" name="Title 1">
             <a:extLst>
               <a:ext uri="{FF2B5EF4-FFF2-40B4-BE49-F238E27FC236}">
-                <a16:creationId xmlns:a16="http://schemas.microsoft.com/office/drawing/2014/main" id="{4DCEF1CF-F981-8377-9EEC-719FFF735214}"/>
+                <a16:creationId xmlns:a16="http://schemas.microsoft.com/office/drawing/2014/main" id="{E5814417-B462-EB26-545D-F79EC1F311A4}"/>
               </a:ext>
             </a:extLst>
           </p:cNvPr>
@@ -6635,7 +7120,7 @@
           <a:p>
             <a:r>
               <a:rPr lang="en-US" dirty="0"/>
-              <a:t>Strategy Service</a:t>
+              <a:t>Example Data Service /docs</a:t>
             </a:r>
           </a:p>
         </p:txBody>
@@ -6645,7 +7130,7 @@
           <p:cNvPr id="3" name="Content Placeholder 2">
             <a:extLst>
               <a:ext uri="{FF2B5EF4-FFF2-40B4-BE49-F238E27FC236}">
-                <a16:creationId xmlns:a16="http://schemas.microsoft.com/office/drawing/2014/main" id="{BA254B4C-2765-0832-B968-B371B3A6B664}"/>
+                <a16:creationId xmlns:a16="http://schemas.microsoft.com/office/drawing/2014/main" id="{0BBB5A8B-4F6C-D932-CA46-64AA57C7FD73}"/>
               </a:ext>
             </a:extLst>
           </p:cNvPr>
@@ -6656,71 +7141,137 @@
             <p:ph idx="1"/>
           </p:nvPr>
         </p:nvSpPr>
-        <p:spPr/>
+        <p:spPr>
+          <a:xfrm>
+            <a:off x="838200" y="1690688"/>
+            <a:ext cx="4196786" cy="4351338"/>
+          </a:xfrm>
+        </p:spPr>
         <p:txBody>
           <a:bodyPr/>
           <a:lstStyle/>
           <a:p>
             <a:r>
-              <a:rPr lang="en-US" dirty="0"/>
-              <a:t>Responsibilities:</a:t>
-            </a:r>
-          </a:p>
-          <a:p>
-            <a:pPr lvl="1"/>
-            <a:r>
-              <a:rPr lang="en-US" dirty="0"/>
-              <a:t>Define strategy interfaces (e.g., </a:t>
-            </a:r>
-            <a:r>
-              <a:rPr lang="en-US" dirty="0" err="1"/>
-              <a:t>generate_signals</a:t>
-            </a:r>
-            <a:r>
-              <a:rPr lang="en-US" dirty="0"/>
-              <a:t>(data))</a:t>
-            </a:r>
-          </a:p>
-          <a:p>
-            <a:pPr lvl="1"/>
-            <a:r>
-              <a:rPr lang="en-US" dirty="0"/>
-              <a:t>Call data service to pull needed history</a:t>
-            </a:r>
-          </a:p>
-          <a:p>
-            <a:pPr lvl="1"/>
-            <a:r>
-              <a:rPr lang="en-US" dirty="0"/>
-              <a:t>Compute signals (buy/sell/hold, target weights)</a:t>
-            </a:r>
-          </a:p>
-          <a:p>
-            <a:pPr lvl="1"/>
-            <a:r>
-              <a:rPr lang="en-US" dirty="0"/>
-              <a:t>Expose:</a:t>
-            </a:r>
-          </a:p>
-          <a:p>
-            <a:pPr lvl="2"/>
-            <a:r>
-              <a:rPr lang="en-US" dirty="0"/>
-              <a:t>POST /run-strategy → returns signals or target weights</a:t>
-            </a:r>
-          </a:p>
-          <a:p>
-            <a:r>
-              <a:rPr lang="en-US" dirty="0"/>
-              <a:t>Nice touch: Support multiple strategies via a plug-in style design.</a:t>
-            </a:r>
-          </a:p>
-        </p:txBody>
-      </p:sp>
+              <a:rPr lang="en-US" sz="2000" dirty="0"/>
+              <a:t>http//:localhost:8001/docs</a:t>
+            </a:r>
+          </a:p>
+          <a:p>
+            <a:r>
+              <a:rPr lang="en-US" sz="2000" dirty="0"/>
+              <a:t>Here we will try getting the latest price for AAPL</a:t>
+            </a:r>
+          </a:p>
+          <a:p>
+            <a:r>
+              <a:rPr lang="en-US" sz="2000" dirty="0"/>
+              <a:t>Enter AAPL as a string and it will return the current price and the timestamp for </a:t>
+            </a:r>
+            <a:r>
+              <a:rPr lang="en-US" sz="2000"/>
+              <a:t>this executio</a:t>
+            </a:r>
+            <a:r>
+              <a:rPr lang="en-US" sz="2000" dirty="0"/>
+              <a:t>n</a:t>
+            </a:r>
+          </a:p>
+        </p:txBody>
+      </p:sp>
+      <p:pic>
+        <p:nvPicPr>
+          <p:cNvPr id="5" name="Picture 4">
+            <a:extLst>
+              <a:ext uri="{FF2B5EF4-FFF2-40B4-BE49-F238E27FC236}">
+                <a16:creationId xmlns:a16="http://schemas.microsoft.com/office/drawing/2014/main" id="{63FE2DBE-90EB-0C45-73D9-D7CA900B7AD0}"/>
+              </a:ext>
+            </a:extLst>
+          </p:cNvPr>
+          <p:cNvPicPr>
+            <a:picLocks noChangeAspect="1"/>
+          </p:cNvPicPr>
+          <p:nvPr/>
+        </p:nvPicPr>
+        <p:blipFill>
+          <a:blip r:embed="rId2"/>
+          <a:stretch>
+            <a:fillRect/>
+          </a:stretch>
+        </p:blipFill>
+        <p:spPr>
+          <a:xfrm>
+            <a:off x="5241958" y="1179294"/>
+            <a:ext cx="6950042" cy="1470787"/>
+          </a:xfrm>
+          <a:prstGeom prst="rect">
+            <a:avLst/>
+          </a:prstGeom>
+        </p:spPr>
+      </p:pic>
+      <p:pic>
+        <p:nvPicPr>
+          <p:cNvPr id="7" name="Picture 6">
+            <a:extLst>
+              <a:ext uri="{FF2B5EF4-FFF2-40B4-BE49-F238E27FC236}">
+                <a16:creationId xmlns:a16="http://schemas.microsoft.com/office/drawing/2014/main" id="{87223BDF-F83C-062B-51A6-01AD28C702D6}"/>
+              </a:ext>
+            </a:extLst>
+          </p:cNvPr>
+          <p:cNvPicPr>
+            <a:picLocks noChangeAspect="1"/>
+          </p:cNvPicPr>
+          <p:nvPr/>
+        </p:nvPicPr>
+        <p:blipFill>
+          <a:blip r:embed="rId3"/>
+          <a:stretch>
+            <a:fillRect/>
+          </a:stretch>
+        </p:blipFill>
+        <p:spPr>
+          <a:xfrm>
+            <a:off x="5424854" y="2826107"/>
+            <a:ext cx="6767146" cy="3215919"/>
+          </a:xfrm>
+          <a:prstGeom prst="rect">
+            <a:avLst/>
+          </a:prstGeom>
+        </p:spPr>
+      </p:pic>
+      <p:pic>
+        <p:nvPicPr>
+          <p:cNvPr id="9" name="Picture 8">
+            <a:extLst>
+              <a:ext uri="{FF2B5EF4-FFF2-40B4-BE49-F238E27FC236}">
+                <a16:creationId xmlns:a16="http://schemas.microsoft.com/office/drawing/2014/main" id="{5406370F-12E0-3A9D-7097-04E76CC48FE0}"/>
+              </a:ext>
+            </a:extLst>
+          </p:cNvPr>
+          <p:cNvPicPr>
+            <a:picLocks noChangeAspect="1"/>
+          </p:cNvPicPr>
+          <p:nvPr/>
+        </p:nvPicPr>
+        <p:blipFill>
+          <a:blip r:embed="rId4"/>
+          <a:stretch>
+            <a:fillRect/>
+          </a:stretch>
+        </p:blipFill>
+        <p:spPr>
+          <a:xfrm>
+            <a:off x="0" y="5059513"/>
+            <a:ext cx="6454699" cy="1600339"/>
+          </a:xfrm>
+          <a:prstGeom prst="rect">
+            <a:avLst/>
+          </a:prstGeom>
+        </p:spPr>
+      </p:pic>
     </p:spTree>
     <p:extLst>
       <p:ext uri="{BB962C8B-B14F-4D97-AF65-F5344CB8AC3E}">
-        <p14:creationId xmlns:p14="http://schemas.microsoft.com/office/powerpoint/2010/main" val="1970380334"/>
+        <p14:creationId xmlns:p14="http://schemas.microsoft.com/office/powerpoint/2010/main" val="1700740987"/>
       </p:ext>
     </p:extLst>
   </p:cSld>
@@ -6752,7 +7303,7 @@
           <p:cNvPr id="2" name="Title 1">
             <a:extLst>
               <a:ext uri="{FF2B5EF4-FFF2-40B4-BE49-F238E27FC236}">
-                <a16:creationId xmlns:a16="http://schemas.microsoft.com/office/drawing/2014/main" id="{3020C385-061B-DFF4-22BA-1E99B25FEA0F}"/>
+                <a16:creationId xmlns:a16="http://schemas.microsoft.com/office/drawing/2014/main" id="{95F66B3A-B224-01CD-EAAC-C99D90E8B1D9}"/>
               </a:ext>
             </a:extLst>
           </p:cNvPr>
@@ -6770,7 +7321,7 @@
           <a:p>
             <a:r>
               <a:rPr lang="en-US" dirty="0"/>
-              <a:t>Portfolio Service</a:t>
+              <a:t>Data Service</a:t>
             </a:r>
           </a:p>
         </p:txBody>
@@ -6780,7 +7331,7 @@
           <p:cNvPr id="3" name="Content Placeholder 2">
             <a:extLst>
               <a:ext uri="{FF2B5EF4-FFF2-40B4-BE49-F238E27FC236}">
-                <a16:creationId xmlns:a16="http://schemas.microsoft.com/office/drawing/2014/main" id="{1B86A073-9C9F-E90E-2B6F-1F5DF496956E}"/>
+                <a16:creationId xmlns:a16="http://schemas.microsoft.com/office/drawing/2014/main" id="{D62343FD-2382-76DD-86D6-19574C03C14C}"/>
               </a:ext>
             </a:extLst>
           </p:cNvPr>
@@ -6807,61 +7358,46 @@
             <a:pPr lvl="1"/>
             <a:r>
               <a:rPr lang="en-US" dirty="0"/>
-              <a:t>Maintain current positions, cash, and </a:t>
+              <a:t>Maintains Symbol Universe Table – Symbols we want to collect OHLCV market data on daily</a:t>
+            </a:r>
+          </a:p>
+          <a:p>
+            <a:pPr lvl="1"/>
+            <a:r>
+              <a:rPr lang="en-US" dirty="0"/>
+              <a:t>Maintains </a:t>
             </a:r>
             <a:r>
               <a:rPr lang="en-US" dirty="0" err="1"/>
-              <a:t>PnL</a:t>
-            </a:r>
+              <a:t>IntraDay</a:t>
+            </a:r>
+            <a:r>
+              <a:rPr lang="en-US" dirty="0"/>
+              <a:t> Watchlist Table – Symbols that one or more Strategy service requires intraday data on for determining stop loss / take profit fills</a:t>
+            </a:r>
+          </a:p>
+          <a:p>
+            <a:pPr lvl="1"/>
+            <a:r>
+              <a:rPr lang="en-US" dirty="0"/>
+              <a:t>Fetches and stores latest prices</a:t>
+            </a:r>
+          </a:p>
+          <a:p>
+            <a:r>
+              <a:rPr lang="en-US" dirty="0"/>
+              <a:t>Why it matters: Everything downstream depends on clean, consistent data. All of the data fetching, cleaning and serving is centralized to one place</a:t>
+            </a:r>
+          </a:p>
+          <a:p>
             <a:endParaRPr lang="en-US" dirty="0"/>
-          </a:p>
-          <a:p>
-            <a:pPr lvl="1"/>
-            <a:r>
-              <a:rPr lang="en-US" dirty="0"/>
-              <a:t>Accept signals/target weights → convert to orders</a:t>
-            </a:r>
-          </a:p>
-          <a:p>
-            <a:pPr lvl="1"/>
-            <a:r>
-              <a:rPr lang="en-US" dirty="0"/>
-              <a:t>Track fills/trades (from execution service)</a:t>
-            </a:r>
-          </a:p>
-          <a:p>
-            <a:pPr lvl="1"/>
-            <a:r>
-              <a:rPr lang="en-US" dirty="0"/>
-              <a:t>Expose:</a:t>
-            </a:r>
-          </a:p>
-          <a:p>
-            <a:pPr lvl="2"/>
-            <a:r>
-              <a:rPr lang="en-US" dirty="0"/>
-              <a:t>GET /portfolio</a:t>
-            </a:r>
-          </a:p>
-          <a:p>
-            <a:pPr lvl="2"/>
-            <a:r>
-              <a:rPr lang="en-US" dirty="0"/>
-              <a:t>POST /rebalance (given target weights)</a:t>
-            </a:r>
-          </a:p>
-          <a:p>
-            <a:r>
-              <a:rPr lang="en-US" dirty="0"/>
-              <a:t>Key concept: Separate “what we want” (signals) from “what we have” (portfolio).</a:t>
-            </a:r>
           </a:p>
         </p:txBody>
       </p:sp>
     </p:spTree>
     <p:extLst>
       <p:ext uri="{BB962C8B-B14F-4D97-AF65-F5344CB8AC3E}">
-        <p14:creationId xmlns:p14="http://schemas.microsoft.com/office/powerpoint/2010/main" val="377062414"/>
+        <p14:creationId xmlns:p14="http://schemas.microsoft.com/office/powerpoint/2010/main" val="252910237"/>
       </p:ext>
     </p:extLst>
   </p:cSld>
@@ -6893,7 +7429,7 @@
           <p:cNvPr id="2" name="Title 1">
             <a:extLst>
               <a:ext uri="{FF2B5EF4-FFF2-40B4-BE49-F238E27FC236}">
-                <a16:creationId xmlns:a16="http://schemas.microsoft.com/office/drawing/2014/main" id="{CC21E9AB-CEFC-8065-3552-3C2A0F23920F}"/>
+                <a16:creationId xmlns:a16="http://schemas.microsoft.com/office/drawing/2014/main" id="{4DCEF1CF-F981-8377-9EEC-719FFF735214}"/>
               </a:ext>
             </a:extLst>
           </p:cNvPr>
@@ -6911,7 +7447,7 @@
           <a:p>
             <a:r>
               <a:rPr lang="en-US" dirty="0"/>
-              <a:t>Risk Service</a:t>
+              <a:t>Strategy Service</a:t>
             </a:r>
           </a:p>
         </p:txBody>
@@ -6921,7 +7457,7 @@
           <p:cNvPr id="3" name="Content Placeholder 2">
             <a:extLst>
               <a:ext uri="{FF2B5EF4-FFF2-40B4-BE49-F238E27FC236}">
-                <a16:creationId xmlns:a16="http://schemas.microsoft.com/office/drawing/2014/main" id="{F77B2BBE-26E9-1355-EF06-D132B5A746E1}"/>
+                <a16:creationId xmlns:a16="http://schemas.microsoft.com/office/drawing/2014/main" id="{BA254B4C-2765-0832-B968-B371B3A6B664}"/>
               </a:ext>
             </a:extLst>
           </p:cNvPr>
@@ -6948,49 +7484,36 @@
             <a:pPr lvl="1"/>
             <a:r>
               <a:rPr lang="en-US" dirty="0"/>
-              <a:t>Compute:</a:t>
+              <a:t>Brains of the platform</a:t>
             </a:r>
           </a:p>
           <a:p>
             <a:pPr lvl="1"/>
             <a:r>
               <a:rPr lang="en-US" dirty="0"/>
-              <a:t>Volatility, drawdown, exposure by asset/sector, leverage, etc.</a:t>
+              <a:t>Each strategy will be </a:t>
+            </a:r>
+            <a:r>
+              <a:rPr lang="en-US" dirty="0" err="1"/>
+              <a:t>uinique</a:t>
+            </a:r>
+            <a:r>
+              <a:rPr lang="en-US" dirty="0"/>
+              <a:t>, but the general responsibility is to determine which symbols we want to evaluate, determine when to generate a buy order based on a certain rule set and what to set the take profit and stop loss sell orders at</a:t>
             </a:r>
           </a:p>
           <a:p>
             <a:pPr lvl="1"/>
             <a:r>
               <a:rPr lang="en-US" dirty="0"/>
-              <a:t>Enforce constraints:</a:t>
+              <a:t>The Strategy service will also evaluate the price action for symbols it has open positions on for when the stop loss or take profit prices are hit.</a:t>
             </a:r>
           </a:p>
           <a:p>
             <a:pPr lvl="1"/>
             <a:r>
               <a:rPr lang="en-US" dirty="0"/>
-              <a:t>Block/reduce orders that violate risk rules</a:t>
-            </a:r>
-          </a:p>
-          <a:p>
-            <a:pPr lvl="1"/>
-            <a:r>
-              <a:rPr lang="en-US" dirty="0"/>
-              <a:t>Expose:</a:t>
-            </a:r>
-          </a:p>
-          <a:p>
-            <a:pPr lvl="2"/>
-            <a:r>
-              <a:rPr lang="en-US" dirty="0"/>
-              <a:t>POST /check-orders (returns approved/trimmed orders + warnings)</a:t>
-            </a:r>
-          </a:p>
-          <a:p>
-            <a:pPr lvl="2"/>
-            <a:r>
-              <a:rPr lang="en-US" dirty="0"/>
-              <a:t>GET /risk-metrics</a:t>
+              <a:t>Details on specific “IPO Strategy” on following slide</a:t>
             </a:r>
           </a:p>
         </p:txBody>
@@ -6998,7 +7521,7 @@
     </p:spTree>
     <p:extLst>
       <p:ext uri="{BB962C8B-B14F-4D97-AF65-F5344CB8AC3E}">
-        <p14:creationId xmlns:p14="http://schemas.microsoft.com/office/powerpoint/2010/main" val="4231797650"/>
+        <p14:creationId xmlns:p14="http://schemas.microsoft.com/office/powerpoint/2010/main" val="1970380334"/>
       </p:ext>
     </p:extLst>
   </p:cSld>
@@ -7030,7 +7553,7 @@
           <p:cNvPr id="2" name="Title 1">
             <a:extLst>
               <a:ext uri="{FF2B5EF4-FFF2-40B4-BE49-F238E27FC236}">
-                <a16:creationId xmlns:a16="http://schemas.microsoft.com/office/drawing/2014/main" id="{EF991D1D-6992-B032-23B2-41A7A13C4C4F}"/>
+                <a16:creationId xmlns:a16="http://schemas.microsoft.com/office/drawing/2014/main" id="{5E0084AC-1150-20D4-3D29-5164D82C97B2}"/>
               </a:ext>
             </a:extLst>
           </p:cNvPr>
@@ -7048,7 +7571,7 @@
           <a:p>
             <a:r>
               <a:rPr lang="en-US" dirty="0"/>
-              <a:t>Execution Service</a:t>
+              <a:t>IPO Strategy</a:t>
             </a:r>
           </a:p>
         </p:txBody>
@@ -7058,7 +7581,7 @@
           <p:cNvPr id="3" name="Content Placeholder 2">
             <a:extLst>
               <a:ext uri="{FF2B5EF4-FFF2-40B4-BE49-F238E27FC236}">
-                <a16:creationId xmlns:a16="http://schemas.microsoft.com/office/drawing/2014/main" id="{D855AE09-8A09-72AC-4D28-6B264E61F5AA}"/>
+                <a16:creationId xmlns:a16="http://schemas.microsoft.com/office/drawing/2014/main" id="{DDC3C967-4A31-7089-983A-0F063AC948D1}"/>
               </a:ext>
             </a:extLst>
           </p:cNvPr>
@@ -7072,55 +7595,125 @@
         <p:spPr/>
         <p:txBody>
           <a:bodyPr>
-            <a:normAutofit/>
+            <a:normAutofit fontScale="92500" lnSpcReduction="20000"/>
           </a:bodyPr>
           <a:lstStyle/>
           <a:p>
             <a:r>
               <a:rPr lang="en-US" dirty="0"/>
-              <a:t>Responsibilities:</a:t>
+              <a:t>Current strategy = “</a:t>
+            </a:r>
+            <a:r>
+              <a:rPr lang="en-US" dirty="0" err="1"/>
+              <a:t>IPO_Strategy</a:t>
+            </a:r>
+            <a:r>
+              <a:rPr lang="en-US" dirty="0"/>
+              <a:t>”:</a:t>
             </a:r>
           </a:p>
           <a:p>
             <a:pPr lvl="1"/>
             <a:r>
               <a:rPr lang="en-US" dirty="0"/>
-              <a:t>Take orders from portfolio service (after risk check)</a:t>
+              <a:t>Scrapes webpage for new companies that have an upcoming IPO. </a:t>
             </a:r>
           </a:p>
           <a:p>
             <a:pPr lvl="1"/>
             <a:r>
               <a:rPr lang="en-US" dirty="0"/>
-              <a:t>In v1: simulate fills using last/close price</a:t>
+              <a:t>Once a new symbol is detected, that symbol is added to </a:t>
+            </a:r>
+            <a:r>
+              <a:rPr lang="en-US" dirty="0" err="1"/>
+              <a:t>DataService’s</a:t>
+            </a:r>
+            <a:r>
+              <a:rPr lang="en-US" dirty="0"/>
+              <a:t> symbol universe and daily OHLCV data starts being stored. </a:t>
             </a:r>
           </a:p>
           <a:p>
             <a:pPr lvl="1"/>
             <a:r>
               <a:rPr lang="en-US" dirty="0"/>
-              <a:t>Optionally: integrate a paper trading API later (Alpaca, Interactive Brokers, etc.)</a:t>
+              <a:t>The symbol is also added the </a:t>
+            </a:r>
+            <a:r>
+              <a:rPr lang="en-US" dirty="0" err="1"/>
+              <a:t>the</a:t>
+            </a:r>
+            <a:r>
+              <a:rPr lang="en-US" dirty="0"/>
+              <a:t> </a:t>
+            </a:r>
+            <a:r>
+              <a:rPr lang="en-US" dirty="0" err="1"/>
+              <a:t>IPO_Service’s</a:t>
+            </a:r>
+            <a:r>
+              <a:rPr lang="en-US" dirty="0"/>
+              <a:t> </a:t>
+            </a:r>
+            <a:r>
+              <a:rPr lang="en-US" dirty="0" err="1"/>
+              <a:t>IPOEvent</a:t>
+            </a:r>
+            <a:r>
+              <a:rPr lang="en-US" dirty="0"/>
+              <a:t> table. </a:t>
             </a:r>
           </a:p>
           <a:p>
             <a:pPr lvl="1"/>
             <a:r>
               <a:rPr lang="en-US" dirty="0"/>
-              <a:t>Expose:</a:t>
-            </a:r>
-          </a:p>
-          <a:p>
-            <a:pPr lvl="2"/>
-            <a:r>
-              <a:rPr lang="en-US" dirty="0"/>
-              <a:t>POST /execute-orders</a:t>
-            </a:r>
-          </a:p>
-          <a:p>
-            <a:pPr lvl="2"/>
-            <a:r>
-              <a:rPr lang="en-US" dirty="0"/>
-              <a:t>GET /orders, GET /trades</a:t>
+              <a:t>The strategy monitors time and waits until the IPO day is reached.</a:t>
+            </a:r>
+          </a:p>
+          <a:p>
+            <a:pPr lvl="1"/>
+            <a:r>
+              <a:rPr lang="en-US" dirty="0"/>
+              <a:t>On the day of the Symbol’s IPO, the strategy saves off the max(</a:t>
+            </a:r>
+            <a:r>
+              <a:rPr lang="en-US" dirty="0" err="1"/>
+              <a:t>open_price,close_price</a:t>
+            </a:r>
+            <a:r>
+              <a:rPr lang="en-US" dirty="0"/>
+              <a:t>). </a:t>
+            </a:r>
+          </a:p>
+          <a:p>
+            <a:pPr lvl="1"/>
+            <a:r>
+              <a:rPr lang="en-US" dirty="0"/>
+              <a:t>A buy signal is generated from the strategy after the first day the </a:t>
+            </a:r>
+            <a:r>
+              <a:rPr lang="en-US" dirty="0" err="1"/>
+              <a:t>the</a:t>
+            </a:r>
+            <a:r>
+              <a:rPr lang="en-US" dirty="0"/>
+              <a:t> symbol closes over the previous high price.</a:t>
+            </a:r>
+          </a:p>
+          <a:p>
+            <a:pPr lvl="1"/>
+            <a:r>
+              <a:rPr lang="en-US" dirty="0"/>
+              <a:t>The take profit is set at 20% above buy price, stop loss is set 10% below buy price.</a:t>
+            </a:r>
+          </a:p>
+          <a:p>
+            <a:pPr lvl="1"/>
+            <a:r>
+              <a:rPr lang="en-US" dirty="0"/>
+              <a:t>The IPO Strategy service streams intraday data from the Market Data Service and initiates a sell order when either of these prices are hit</a:t>
             </a:r>
           </a:p>
         </p:txBody>
@@ -7128,7 +7721,7 @@
     </p:spTree>
     <p:extLst>
       <p:ext uri="{BB962C8B-B14F-4D97-AF65-F5344CB8AC3E}">
-        <p14:creationId xmlns:p14="http://schemas.microsoft.com/office/powerpoint/2010/main" val="1836074655"/>
+        <p14:creationId xmlns:p14="http://schemas.microsoft.com/office/powerpoint/2010/main" val="2224721895"/>
       </p:ext>
     </p:extLst>
   </p:cSld>

</xml_diff>

<commit_message>
Restructure the ipo strategy pipelines and properly schedule them in app tasks
</commit_message>
<xml_diff>
--- a/00_system_architecture/quant_management_platform_architecture.pptx
+++ b/00_system_architecture/quant_management_platform_architecture.pptx
@@ -5,7 +5,7 @@
     <p:sldMasterId id="2147483648" r:id="rId1"/>
   </p:sldMasterIdLst>
   <p:notesMasterIdLst>
-    <p:notesMasterId r:id="rId15"/>
+    <p:notesMasterId r:id="rId16"/>
   </p:notesMasterIdLst>
   <p:sldIdLst>
     <p:sldId id="256" r:id="rId2"/>
@@ -17,10 +17,11 @@
     <p:sldId id="259" r:id="rId8"/>
     <p:sldId id="260" r:id="rId9"/>
     <p:sldId id="266" r:id="rId10"/>
-    <p:sldId id="261" r:id="rId11"/>
-    <p:sldId id="262" r:id="rId12"/>
-    <p:sldId id="263" r:id="rId13"/>
-    <p:sldId id="264" r:id="rId14"/>
+    <p:sldId id="269" r:id="rId11"/>
+    <p:sldId id="261" r:id="rId12"/>
+    <p:sldId id="262" r:id="rId13"/>
+    <p:sldId id="263" r:id="rId14"/>
+    <p:sldId id="264" r:id="rId15"/>
   </p:sldIdLst>
   <p:sldSz cx="12192000" cy="6858000"/>
   <p:notesSz cx="6858000" cy="9144000"/>
@@ -209,7 +210,7 @@
           <a:p>
             <a:fld id="{70866825-8C01-4766-8F79-C41ECFD9525D}" type="datetimeFigureOut">
               <a:rPr lang="en-US" smtClean="0"/>
-              <a:t>1/20/2026</a:t>
+              <a:t>2/1/2026</a:t>
             </a:fld>
             <a:endParaRPr lang="en-US"/>
           </a:p>
@@ -707,7 +708,7 @@
           <a:p>
             <a:fld id="{7CD6D201-3712-4708-B8BD-34638CB62F40}" type="datetimeFigureOut">
               <a:rPr lang="en-US" smtClean="0"/>
-              <a:t>1/20/2026</a:t>
+              <a:t>2/1/2026</a:t>
             </a:fld>
             <a:endParaRPr lang="en-US"/>
           </a:p>
@@ -905,7 +906,7 @@
           <a:p>
             <a:fld id="{7CD6D201-3712-4708-B8BD-34638CB62F40}" type="datetimeFigureOut">
               <a:rPr lang="en-US" smtClean="0"/>
-              <a:t>1/20/2026</a:t>
+              <a:t>2/1/2026</a:t>
             </a:fld>
             <a:endParaRPr lang="en-US"/>
           </a:p>
@@ -1113,7 +1114,7 @@
           <a:p>
             <a:fld id="{7CD6D201-3712-4708-B8BD-34638CB62F40}" type="datetimeFigureOut">
               <a:rPr lang="en-US" smtClean="0"/>
-              <a:t>1/20/2026</a:t>
+              <a:t>2/1/2026</a:t>
             </a:fld>
             <a:endParaRPr lang="en-US"/>
           </a:p>
@@ -1311,7 +1312,7 @@
           <a:p>
             <a:fld id="{7CD6D201-3712-4708-B8BD-34638CB62F40}" type="datetimeFigureOut">
               <a:rPr lang="en-US" smtClean="0"/>
-              <a:t>1/20/2026</a:t>
+              <a:t>2/1/2026</a:t>
             </a:fld>
             <a:endParaRPr lang="en-US"/>
           </a:p>
@@ -1586,7 +1587,7 @@
           <a:p>
             <a:fld id="{7CD6D201-3712-4708-B8BD-34638CB62F40}" type="datetimeFigureOut">
               <a:rPr lang="en-US" smtClean="0"/>
-              <a:t>1/20/2026</a:t>
+              <a:t>2/1/2026</a:t>
             </a:fld>
             <a:endParaRPr lang="en-US"/>
           </a:p>
@@ -1851,7 +1852,7 @@
           <a:p>
             <a:fld id="{7CD6D201-3712-4708-B8BD-34638CB62F40}" type="datetimeFigureOut">
               <a:rPr lang="en-US" smtClean="0"/>
-              <a:t>1/20/2026</a:t>
+              <a:t>2/1/2026</a:t>
             </a:fld>
             <a:endParaRPr lang="en-US"/>
           </a:p>
@@ -2263,7 +2264,7 @@
           <a:p>
             <a:fld id="{7CD6D201-3712-4708-B8BD-34638CB62F40}" type="datetimeFigureOut">
               <a:rPr lang="en-US" smtClean="0"/>
-              <a:t>1/20/2026</a:t>
+              <a:t>2/1/2026</a:t>
             </a:fld>
             <a:endParaRPr lang="en-US"/>
           </a:p>
@@ -2404,7 +2405,7 @@
           <a:p>
             <a:fld id="{7CD6D201-3712-4708-B8BD-34638CB62F40}" type="datetimeFigureOut">
               <a:rPr lang="en-US" smtClean="0"/>
-              <a:t>1/20/2026</a:t>
+              <a:t>2/1/2026</a:t>
             </a:fld>
             <a:endParaRPr lang="en-US"/>
           </a:p>
@@ -2517,7 +2518,7 @@
           <a:p>
             <a:fld id="{7CD6D201-3712-4708-B8BD-34638CB62F40}" type="datetimeFigureOut">
               <a:rPr lang="en-US" smtClean="0"/>
-              <a:t>1/20/2026</a:t>
+              <a:t>2/1/2026</a:t>
             </a:fld>
             <a:endParaRPr lang="en-US"/>
           </a:p>
@@ -2828,7 +2829,7 @@
           <a:p>
             <a:fld id="{7CD6D201-3712-4708-B8BD-34638CB62F40}" type="datetimeFigureOut">
               <a:rPr lang="en-US" smtClean="0"/>
-              <a:t>1/20/2026</a:t>
+              <a:t>2/1/2026</a:t>
             </a:fld>
             <a:endParaRPr lang="en-US"/>
           </a:p>
@@ -3116,7 +3117,7 @@
           <a:p>
             <a:fld id="{7CD6D201-3712-4708-B8BD-34638CB62F40}" type="datetimeFigureOut">
               <a:rPr lang="en-US" smtClean="0"/>
-              <a:t>1/20/2026</a:t>
+              <a:t>2/1/2026</a:t>
             </a:fld>
             <a:endParaRPr lang="en-US"/>
           </a:p>
@@ -3357,7 +3358,7 @@
           <a:p>
             <a:fld id="{7CD6D201-3712-4708-B8BD-34638CB62F40}" type="datetimeFigureOut">
               <a:rPr lang="en-US" smtClean="0"/>
-              <a:t>1/20/2026</a:t>
+              <a:t>2/1/2026</a:t>
             </a:fld>
             <a:endParaRPr lang="en-US"/>
           </a:p>
@@ -3888,7 +3889,7 @@
           <p:cNvPr id="2" name="Title 1">
             <a:extLst>
               <a:ext uri="{FF2B5EF4-FFF2-40B4-BE49-F238E27FC236}">
-                <a16:creationId xmlns:a16="http://schemas.microsoft.com/office/drawing/2014/main" id="{3020C385-061B-DFF4-22BA-1E99B25FEA0F}"/>
+                <a16:creationId xmlns:a16="http://schemas.microsoft.com/office/drawing/2014/main" id="{6E0CF832-5260-5EF6-EA1F-A7958CBE046F}"/>
               </a:ext>
             </a:extLst>
           </p:cNvPr>
@@ -3899,14 +3900,19 @@
             <p:ph type="title"/>
           </p:nvPr>
         </p:nvSpPr>
-        <p:spPr/>
+        <p:spPr>
+          <a:xfrm>
+            <a:off x="838200" y="152400"/>
+            <a:ext cx="10515600" cy="788761"/>
+          </a:xfrm>
+        </p:spPr>
         <p:txBody>
           <a:bodyPr/>
           <a:lstStyle/>
           <a:p>
             <a:r>
               <a:rPr lang="en-US" dirty="0"/>
-              <a:t>Portfolio Service</a:t>
+              <a:t>IPO Strategy Pipelines and schedule</a:t>
             </a:r>
           </a:p>
         </p:txBody>
@@ -3916,7 +3922,7 @@
           <p:cNvPr id="3" name="Content Placeholder 2">
             <a:extLst>
               <a:ext uri="{FF2B5EF4-FFF2-40B4-BE49-F238E27FC236}">
-                <a16:creationId xmlns:a16="http://schemas.microsoft.com/office/drawing/2014/main" id="{1B86A073-9C9F-E90E-2B6F-1F5DF496956E}"/>
+                <a16:creationId xmlns:a16="http://schemas.microsoft.com/office/drawing/2014/main" id="{C60E3047-C2A3-F4AF-4D18-E64A25AFCC45}"/>
               </a:ext>
             </a:extLst>
           </p:cNvPr>
@@ -3927,27 +3933,218 @@
             <p:ph idx="1"/>
           </p:nvPr>
         </p:nvSpPr>
-        <p:spPr/>
+        <p:spPr>
+          <a:xfrm>
+            <a:off x="838200" y="941161"/>
+            <a:ext cx="10515600" cy="5764439"/>
+          </a:xfrm>
+        </p:spPr>
         <p:txBody>
           <a:bodyPr>
-            <a:normAutofit/>
+            <a:normAutofit fontScale="47500" lnSpcReduction="20000"/>
           </a:bodyPr>
           <a:lstStyle/>
           <a:p>
             <a:r>
               <a:rPr lang="en-US" dirty="0"/>
-              <a:t>Responsibilities:</a:t>
+              <a:t>Ingestion Pipeline:</a:t>
             </a:r>
           </a:p>
           <a:p>
             <a:pPr lvl="1"/>
             <a:r>
               <a:rPr lang="en-US" dirty="0"/>
-              <a:t>Maintain current positions, cash, and </a:t>
+              <a:t>Scrapes </a:t>
             </a:r>
             <a:r>
               <a:rPr lang="en-US" dirty="0" err="1"/>
-              <a:t>PnL</a:t>
+              <a:t>StockAnalysis</a:t>
+            </a:r>
+            <a:r>
+              <a:rPr lang="en-US" dirty="0"/>
+              <a:t> Webpage, Creates a new </a:t>
+            </a:r>
+            <a:r>
+              <a:rPr lang="en-US" dirty="0" err="1"/>
+              <a:t>IPOEvent</a:t>
+            </a:r>
+            <a:r>
+              <a:rPr lang="en-US" dirty="0"/>
+              <a:t> row with state = “DISCOVERED”</a:t>
+            </a:r>
+          </a:p>
+          <a:p>
+            <a:pPr lvl="1"/>
+            <a:r>
+              <a:rPr lang="en-US" dirty="0"/>
+              <a:t>If row for symbol already exists, update if there is new data</a:t>
+            </a:r>
+          </a:p>
+          <a:p>
+            <a:pPr lvl="1"/>
+            <a:r>
+              <a:rPr lang="en-US" dirty="0"/>
+              <a:t>Run every hour to check if IPO date is changed to current day</a:t>
+            </a:r>
+          </a:p>
+          <a:p>
+            <a:r>
+              <a:rPr lang="en-US" dirty="0"/>
+              <a:t>Universe Pipeline:</a:t>
+            </a:r>
+          </a:p>
+          <a:p>
+            <a:pPr lvl="1"/>
+            <a:r>
+              <a:rPr lang="en-US" dirty="0" err="1"/>
+              <a:t>Querys</a:t>
+            </a:r>
+            <a:r>
+              <a:rPr lang="en-US" dirty="0"/>
+              <a:t> </a:t>
+            </a:r>
+            <a:r>
+              <a:rPr lang="en-US" dirty="0" err="1"/>
+              <a:t>IPOEvent</a:t>
+            </a:r>
+            <a:r>
+              <a:rPr lang="en-US" dirty="0"/>
+              <a:t> Table for symbols in state “DISCOVERED” adds them to data service </a:t>
+            </a:r>
+            <a:r>
+              <a:rPr lang="en-US" dirty="0" err="1"/>
+              <a:t>symbolUniverse</a:t>
+            </a:r>
+            <a:r>
+              <a:rPr lang="en-US" dirty="0"/>
+              <a:t> table to start pulling daily OHLCV data</a:t>
+            </a:r>
+          </a:p>
+          <a:p>
+            <a:pPr lvl="1"/>
+            <a:r>
+              <a:rPr lang="en-US" dirty="0"/>
+              <a:t>Sets state = “WATCHING”</a:t>
+            </a:r>
+          </a:p>
+          <a:p>
+            <a:pPr lvl="1"/>
+            <a:r>
+              <a:rPr lang="en-US" dirty="0"/>
+              <a:t>Run immediately after Ingestion Pipeline to add newly found symbols to Universe</a:t>
+            </a:r>
+          </a:p>
+          <a:p>
+            <a:r>
+              <a:rPr lang="en-US" dirty="0"/>
+              <a:t>IPO Day Pipeline:</a:t>
+            </a:r>
+          </a:p>
+          <a:p>
+            <a:pPr lvl="1"/>
+            <a:r>
+              <a:rPr lang="en-US" dirty="0"/>
+              <a:t>Queries </a:t>
+            </a:r>
+            <a:r>
+              <a:rPr lang="en-US" dirty="0" err="1"/>
+              <a:t>IPOEvent</a:t>
+            </a:r>
+            <a:r>
+              <a:rPr lang="en-US" dirty="0"/>
+              <a:t> for “WATCHING” symbols, evaluates if current day is equal to stored </a:t>
+            </a:r>
+            <a:r>
+              <a:rPr lang="en-US" dirty="0" err="1"/>
+              <a:t>ipo_date</a:t>
+            </a:r>
+            <a:r>
+              <a:rPr lang="en-US" dirty="0"/>
+              <a:t>. If so state = “IPO_DAY” if date passed state = “MISSED”</a:t>
+            </a:r>
+          </a:p>
+          <a:p>
+            <a:pPr lvl="1"/>
+            <a:r>
+              <a:rPr lang="en-US" dirty="0"/>
+              <a:t>Run immediately after Universe pipeline in case </a:t>
+            </a:r>
+            <a:r>
+              <a:rPr lang="en-US" dirty="0" err="1"/>
+              <a:t>ipo_dates</a:t>
+            </a:r>
+            <a:r>
+              <a:rPr lang="en-US" dirty="0"/>
+              <a:t> were updated to current day</a:t>
+            </a:r>
+          </a:p>
+          <a:p>
+            <a:r>
+              <a:rPr lang="en-US" dirty="0"/>
+              <a:t>Entry Evaluation Pipeline:</a:t>
+            </a:r>
+          </a:p>
+          <a:p>
+            <a:pPr lvl="1"/>
+            <a:r>
+              <a:rPr lang="en-US" dirty="0"/>
+              <a:t>IPO_DAY - &gt; READY</a:t>
+            </a:r>
+          </a:p>
+          <a:p>
+            <a:pPr lvl="2"/>
+            <a:r>
+              <a:rPr lang="en-US" dirty="0"/>
+              <a:t>Saves off the </a:t>
+            </a:r>
+            <a:r>
+              <a:rPr lang="en-US" dirty="0" err="1"/>
+              <a:t>ipo</a:t>
+            </a:r>
+            <a:r>
+              <a:rPr lang="en-US" dirty="0"/>
+              <a:t> (open) price and the close price on the day of the IPO. Sets state = “READY”</a:t>
+            </a:r>
+          </a:p>
+          <a:p>
+            <a:pPr lvl="3"/>
+            <a:r>
+              <a:rPr lang="en-US" dirty="0"/>
+              <a:t>Sets max(</a:t>
+            </a:r>
+            <a:r>
+              <a:rPr lang="en-US" dirty="0" err="1"/>
+              <a:t>ipo_price,close_price</a:t>
+            </a:r>
+            <a:r>
+              <a:rPr lang="en-US" dirty="0"/>
+              <a:t>) as the highest close for entry evaluation</a:t>
+            </a:r>
+          </a:p>
+          <a:p>
+            <a:pPr lvl="1"/>
+            <a:r>
+              <a:rPr lang="en-US" dirty="0"/>
+              <a:t>READY -&gt; BUY_SIGNAL</a:t>
+            </a:r>
+          </a:p>
+          <a:p>
+            <a:pPr lvl="1"/>
+            <a:r>
+              <a:rPr lang="en-US" dirty="0"/>
+              <a:t>Queries </a:t>
+            </a:r>
+            <a:r>
+              <a:rPr lang="en-US" dirty="0" err="1"/>
+              <a:t>IPOEvent</a:t>
+            </a:r>
+            <a:r>
+              <a:rPr lang="en-US" dirty="0"/>
+              <a:t> for symbols in state = “READY” and where today != </a:t>
+            </a:r>
+            <a:r>
+              <a:rPr lang="en-US" dirty="0" err="1"/>
+              <a:t>ipo_date</a:t>
             </a:r>
             <a:endParaRPr lang="en-US" dirty="0"/>
           </a:p>
@@ -3955,36 +4152,97 @@
             <a:pPr lvl="1"/>
             <a:r>
               <a:rPr lang="en-US" dirty="0"/>
-              <a:t>Track fills/trades (from execution service)</a:t>
+              <a:t>Evaluates the close price for the current day, if close price &gt; </a:t>
+            </a:r>
+            <a:r>
+              <a:rPr lang="en-US" dirty="0" err="1"/>
+              <a:t>highest_close</a:t>
+            </a:r>
+            <a:r>
+              <a:rPr lang="en-US" dirty="0"/>
+              <a:t> set state = “BUY_SIGNAL”</a:t>
             </a:r>
           </a:p>
           <a:p>
             <a:pPr lvl="1"/>
             <a:r>
               <a:rPr lang="en-US" dirty="0"/>
-              <a:t>Expose:</a:t>
-            </a:r>
-          </a:p>
-          <a:p>
-            <a:pPr lvl="2"/>
-            <a:r>
-              <a:rPr lang="en-US" dirty="0"/>
-              <a:t>GET /portfolio</a:t>
-            </a:r>
-          </a:p>
-          <a:p>
-            <a:pPr lvl="2"/>
-            <a:r>
-              <a:rPr lang="en-US" dirty="0"/>
-              <a:t>POST /rebalance (given target weights)</a:t>
-            </a:r>
+              <a:t>Runs every day after market close</a:t>
+            </a:r>
+          </a:p>
+          <a:p>
+            <a:r>
+              <a:rPr lang="en-US" dirty="0"/>
+              <a:t>Buy Signal Pipeline:</a:t>
+            </a:r>
+          </a:p>
+          <a:p>
+            <a:pPr lvl="1"/>
+            <a:r>
+              <a:rPr lang="en-US" dirty="0"/>
+              <a:t>Queries </a:t>
+            </a:r>
+            <a:r>
+              <a:rPr lang="en-US" dirty="0" err="1"/>
+              <a:t>IPOEvent</a:t>
+            </a:r>
+            <a:r>
+              <a:rPr lang="en-US" dirty="0"/>
+              <a:t> for symbols in state = “BUY_SIGNAL”</a:t>
+            </a:r>
+          </a:p>
+          <a:p>
+            <a:pPr lvl="1"/>
+            <a:r>
+              <a:rPr lang="en-US" dirty="0"/>
+              <a:t>Send buy order to execution service as soon as market opens and sets state = “HOLDING” upon successful response from execution service</a:t>
+            </a:r>
+          </a:p>
+          <a:p>
+            <a:pPr lvl="1"/>
+            <a:r>
+              <a:rPr lang="en-US" dirty="0"/>
+              <a:t>Sets the stop loss and take profit prices for exit evaluation pipeline to use, adds symbol/strategy pairing to intraday watchlist for intraday price streaming used by exit evaluation pipeline</a:t>
+            </a:r>
+          </a:p>
+          <a:p>
+            <a:pPr lvl="1"/>
+            <a:r>
+              <a:rPr lang="en-US" dirty="0"/>
+              <a:t>Runs once as soon as market opens (execute buys right as market opens from signal generated night before)</a:t>
+            </a:r>
+          </a:p>
+          <a:p>
+            <a:r>
+              <a:rPr lang="en-US" dirty="0"/>
+              <a:t>Exit Evaluation Pipeline:</a:t>
+            </a:r>
+          </a:p>
+          <a:p>
+            <a:pPr lvl="1"/>
+            <a:r>
+              <a:rPr lang="en-US" dirty="0"/>
+              <a:t>Runs continuously – evaluates intraday price for symbols in state = “HOLDING” to see if stop loss or take profit are hit</a:t>
+            </a:r>
+          </a:p>
+          <a:p>
+            <a:pPr lvl="1"/>
+            <a:r>
+              <a:rPr lang="en-US" dirty="0"/>
+              <a:t>If they are, sends sell order to the execution service and sets state = “EXITED” upon successful execution and removes symbol/strategy pairing from </a:t>
+            </a:r>
+            <a:r>
+              <a:rPr lang="en-US" dirty="0" err="1"/>
+              <a:t>intraday_watchlist</a:t>
+            </a:r>
+            <a:endParaRPr lang="en-US" dirty="0"/>
           </a:p>
         </p:txBody>
       </p:sp>
     </p:spTree>
     <p:extLst>
       <p:ext uri="{BB962C8B-B14F-4D97-AF65-F5344CB8AC3E}">
-        <p14:creationId xmlns:p14="http://schemas.microsoft.com/office/powerpoint/2010/main" val="377062414"/>
+        <p14:creationId xmlns:p14="http://schemas.microsoft.com/office/powerpoint/2010/main" val="2303550660"/>
       </p:ext>
     </p:extLst>
   </p:cSld>
@@ -4016,7 +4274,7 @@
           <p:cNvPr id="2" name="Title 1">
             <a:extLst>
               <a:ext uri="{FF2B5EF4-FFF2-40B4-BE49-F238E27FC236}">
-                <a16:creationId xmlns:a16="http://schemas.microsoft.com/office/drawing/2014/main" id="{CC21E9AB-CEFC-8065-3552-3C2A0F23920F}"/>
+                <a16:creationId xmlns:a16="http://schemas.microsoft.com/office/drawing/2014/main" id="{3020C385-061B-DFF4-22BA-1E99B25FEA0F}"/>
               </a:ext>
             </a:extLst>
           </p:cNvPr>
@@ -4034,7 +4292,7 @@
           <a:p>
             <a:r>
               <a:rPr lang="en-US" dirty="0"/>
-              <a:t>Risk Service – Not yet implemented</a:t>
+              <a:t>Portfolio Service</a:t>
             </a:r>
           </a:p>
         </p:txBody>
@@ -4044,7 +4302,7 @@
           <p:cNvPr id="3" name="Content Placeholder 2">
             <a:extLst>
               <a:ext uri="{FF2B5EF4-FFF2-40B4-BE49-F238E27FC236}">
-                <a16:creationId xmlns:a16="http://schemas.microsoft.com/office/drawing/2014/main" id="{F77B2BBE-26E9-1355-EF06-D132B5A746E1}"/>
+                <a16:creationId xmlns:a16="http://schemas.microsoft.com/office/drawing/2014/main" id="{1B86A073-9C9F-E90E-2B6F-1F5DF496956E}"/>
               </a:ext>
             </a:extLst>
           </p:cNvPr>
@@ -4071,34 +4329,25 @@
             <a:pPr lvl="1"/>
             <a:r>
               <a:rPr lang="en-US" dirty="0"/>
-              <a:t>Compute:</a:t>
-            </a:r>
+              <a:t>Maintain current positions, cash, and </a:t>
+            </a:r>
+            <a:r>
+              <a:rPr lang="en-US" dirty="0" err="1"/>
+              <a:t>PnL</a:t>
+            </a:r>
+            <a:endParaRPr lang="en-US" dirty="0"/>
           </a:p>
           <a:p>
             <a:pPr lvl="1"/>
             <a:r>
               <a:rPr lang="en-US" dirty="0"/>
-              <a:t>Volatility, drawdown, exposure by asset/sector, leverage, etc.</a:t>
+              <a:t>Track fills/trades (from execution service)</a:t>
             </a:r>
           </a:p>
           <a:p>
             <a:pPr lvl="1"/>
             <a:r>
               <a:rPr lang="en-US" dirty="0"/>
-              <a:t>Enforce constraints:</a:t>
-            </a:r>
-          </a:p>
-          <a:p>
-            <a:pPr lvl="1"/>
-            <a:r>
-              <a:rPr lang="en-US" dirty="0"/>
-              <a:t>Block/reduce orders that violate risk rules</a:t>
-            </a:r>
-          </a:p>
-          <a:p>
-            <a:pPr lvl="1"/>
-            <a:r>
-              <a:rPr lang="en-US" dirty="0"/>
               <a:t>Expose:</a:t>
             </a:r>
           </a:p>
@@ -4106,14 +4355,14 @@
             <a:pPr lvl="2"/>
             <a:r>
               <a:rPr lang="en-US" dirty="0"/>
-              <a:t>POST /check-orders (returns approved/trimmed orders + warnings)</a:t>
+              <a:t>GET /portfolio</a:t>
             </a:r>
           </a:p>
           <a:p>
             <a:pPr lvl="2"/>
             <a:r>
               <a:rPr lang="en-US" dirty="0"/>
-              <a:t>GET /risk-metrics</a:t>
+              <a:t>POST /rebalance (given target weights)</a:t>
             </a:r>
           </a:p>
         </p:txBody>
@@ -4121,7 +4370,7 @@
     </p:spTree>
     <p:extLst>
       <p:ext uri="{BB962C8B-B14F-4D97-AF65-F5344CB8AC3E}">
-        <p14:creationId xmlns:p14="http://schemas.microsoft.com/office/powerpoint/2010/main" val="4231797650"/>
+        <p14:creationId xmlns:p14="http://schemas.microsoft.com/office/powerpoint/2010/main" val="377062414"/>
       </p:ext>
     </p:extLst>
   </p:cSld>
@@ -4153,6 +4402,143 @@
           <p:cNvPr id="2" name="Title 1">
             <a:extLst>
               <a:ext uri="{FF2B5EF4-FFF2-40B4-BE49-F238E27FC236}">
+                <a16:creationId xmlns:a16="http://schemas.microsoft.com/office/drawing/2014/main" id="{CC21E9AB-CEFC-8065-3552-3C2A0F23920F}"/>
+              </a:ext>
+            </a:extLst>
+          </p:cNvPr>
+          <p:cNvSpPr>
+            <a:spLocks noGrp="1"/>
+          </p:cNvSpPr>
+          <p:nvPr>
+            <p:ph type="title"/>
+          </p:nvPr>
+        </p:nvSpPr>
+        <p:spPr/>
+        <p:txBody>
+          <a:bodyPr/>
+          <a:lstStyle/>
+          <a:p>
+            <a:r>
+              <a:rPr lang="en-US" dirty="0"/>
+              <a:t>Risk Service – Not yet implemented</a:t>
+            </a:r>
+          </a:p>
+        </p:txBody>
+      </p:sp>
+      <p:sp>
+        <p:nvSpPr>
+          <p:cNvPr id="3" name="Content Placeholder 2">
+            <a:extLst>
+              <a:ext uri="{FF2B5EF4-FFF2-40B4-BE49-F238E27FC236}">
+                <a16:creationId xmlns:a16="http://schemas.microsoft.com/office/drawing/2014/main" id="{F77B2BBE-26E9-1355-EF06-D132B5A746E1}"/>
+              </a:ext>
+            </a:extLst>
+          </p:cNvPr>
+          <p:cNvSpPr>
+            <a:spLocks noGrp="1"/>
+          </p:cNvSpPr>
+          <p:nvPr>
+            <p:ph idx="1"/>
+          </p:nvPr>
+        </p:nvSpPr>
+        <p:spPr/>
+        <p:txBody>
+          <a:bodyPr>
+            <a:normAutofit/>
+          </a:bodyPr>
+          <a:lstStyle/>
+          <a:p>
+            <a:r>
+              <a:rPr lang="en-US" dirty="0"/>
+              <a:t>Responsibilities:</a:t>
+            </a:r>
+          </a:p>
+          <a:p>
+            <a:pPr lvl="1"/>
+            <a:r>
+              <a:rPr lang="en-US" dirty="0"/>
+              <a:t>Compute:</a:t>
+            </a:r>
+          </a:p>
+          <a:p>
+            <a:pPr lvl="1"/>
+            <a:r>
+              <a:rPr lang="en-US" dirty="0"/>
+              <a:t>Volatility, drawdown, exposure by asset/sector, leverage, etc.</a:t>
+            </a:r>
+          </a:p>
+          <a:p>
+            <a:pPr lvl="1"/>
+            <a:r>
+              <a:rPr lang="en-US" dirty="0"/>
+              <a:t>Enforce constraints:</a:t>
+            </a:r>
+          </a:p>
+          <a:p>
+            <a:pPr lvl="1"/>
+            <a:r>
+              <a:rPr lang="en-US" dirty="0"/>
+              <a:t>Block/reduce orders that violate risk rules</a:t>
+            </a:r>
+          </a:p>
+          <a:p>
+            <a:pPr lvl="1"/>
+            <a:r>
+              <a:rPr lang="en-US" dirty="0"/>
+              <a:t>Expose:</a:t>
+            </a:r>
+          </a:p>
+          <a:p>
+            <a:pPr lvl="2"/>
+            <a:r>
+              <a:rPr lang="en-US" dirty="0"/>
+              <a:t>POST /check-orders (returns approved/trimmed orders + warnings)</a:t>
+            </a:r>
+          </a:p>
+          <a:p>
+            <a:pPr lvl="2"/>
+            <a:r>
+              <a:rPr lang="en-US" dirty="0"/>
+              <a:t>GET /risk-metrics</a:t>
+            </a:r>
+          </a:p>
+        </p:txBody>
+      </p:sp>
+    </p:spTree>
+    <p:extLst>
+      <p:ext uri="{BB962C8B-B14F-4D97-AF65-F5344CB8AC3E}">
+        <p14:creationId xmlns:p14="http://schemas.microsoft.com/office/powerpoint/2010/main" val="4231797650"/>
+      </p:ext>
+    </p:extLst>
+  </p:cSld>
+  <p:clrMapOvr>
+    <a:masterClrMapping/>
+  </p:clrMapOvr>
+</p:sld>
+</file>
+
+<file path=ppt/slides/slide13.xml><?xml version="1.0" encoding="utf-8"?>
+<p:sld xmlns:a="http://schemas.openxmlformats.org/drawingml/2006/main" xmlns:r="http://schemas.openxmlformats.org/officeDocument/2006/relationships" xmlns:p="http://schemas.openxmlformats.org/presentationml/2006/main">
+  <p:cSld>
+    <p:spTree>
+      <p:nvGrpSpPr>
+        <p:cNvPr id="1" name=""/>
+        <p:cNvGrpSpPr/>
+        <p:nvPr/>
+      </p:nvGrpSpPr>
+      <p:grpSpPr>
+        <a:xfrm>
+          <a:off x="0" y="0"/>
+          <a:ext cx="0" cy="0"/>
+          <a:chOff x="0" y="0"/>
+          <a:chExt cx="0" cy="0"/>
+        </a:xfrm>
+      </p:grpSpPr>
+      <p:sp>
+        <p:nvSpPr>
+          <p:cNvPr id="2" name="Title 1">
+            <a:extLst>
+              <a:ext uri="{FF2B5EF4-FFF2-40B4-BE49-F238E27FC236}">
                 <a16:creationId xmlns:a16="http://schemas.microsoft.com/office/drawing/2014/main" id="{EF991D1D-6992-B032-23B2-41A7A13C4C4F}"/>
               </a:ext>
             </a:extLst>
@@ -4289,7 +4675,7 @@
 </p:sld>
 </file>
 
-<file path=ppt/slides/slide13.xml><?xml version="1.0" encoding="utf-8"?>
+<file path=ppt/slides/slide14.xml><?xml version="1.0" encoding="utf-8"?>
 <p:sld xmlns:a="http://schemas.openxmlformats.org/drawingml/2006/main" xmlns:r="http://schemas.openxmlformats.org/officeDocument/2006/relationships" xmlns:p="http://schemas.openxmlformats.org/presentationml/2006/main">
   <p:cSld>
     <p:spTree>
@@ -7491,15 +7877,7 @@
             <a:pPr lvl="1"/>
             <a:r>
               <a:rPr lang="en-US" dirty="0"/>
-              <a:t>Each strategy will be </a:t>
-            </a:r>
-            <a:r>
-              <a:rPr lang="en-US" dirty="0" err="1"/>
-              <a:t>uinique</a:t>
-            </a:r>
-            <a:r>
-              <a:rPr lang="en-US" dirty="0"/>
-              <a:t>, but the general responsibility is to determine which symbols we want to evaluate, determine when to generate a buy order based on a certain rule set and what to set the take profit and stop loss sell orders at</a:t>
+              <a:t>Each strategy will be unique, but the general responsibility is to determine which symbols we want to evaluate, determine when to generate a buy order based on a certain rule set and what to set the take profit and stop loss sell orders at</a:t>
             </a:r>
           </a:p>
           <a:p>
@@ -7595,7 +7973,7 @@
         <p:spPr/>
         <p:txBody>
           <a:bodyPr>
-            <a:normAutofit fontScale="92500" lnSpcReduction="20000"/>
+            <a:normAutofit fontScale="85000" lnSpcReduction="10000"/>
           </a:bodyPr>
           <a:lstStyle/>
           <a:p>
@@ -7714,6 +8092,20 @@
             <a:r>
               <a:rPr lang="en-US" dirty="0"/>
               <a:t>The IPO Strategy service streams intraday data from the Market Data Service and initiates a sell order when either of these prices are hit</a:t>
+            </a:r>
+          </a:p>
+          <a:p>
+            <a:pPr lvl="1"/>
+            <a:r>
+              <a:rPr lang="en-US" dirty="0"/>
+              <a:t>State Machine:</a:t>
+            </a:r>
+          </a:p>
+          <a:p>
+            <a:pPr lvl="2"/>
+            <a:r>
+              <a:rPr lang="en-US" dirty="0"/>
+              <a:t>DISCOVERED -&gt; WATCHING-&gt;IPO_DAY-&gt;READY-&gt;BUY_ORDER-&gt;HOLDING-&gt;EXITED</a:t>
             </a:r>
           </a:p>
         </p:txBody>

</xml_diff>